<commit_message>
Repo cleanup: remove one-off scripts, regenerate consistent artifacts
</commit_message>
<xml_diff>
--- a/docs/drift_sense_presentation.pptx
+++ b/docs/drift_sense_presentation.pptx
@@ -5,17 +5,16 @@
     <p:sldMasterId id="2147483648" r:id="rId1"/>
   </p:sldMasterIdLst>
   <p:sldIdLst>
-    <p:sldId id="256" r:id="rId7"/>
-    <p:sldId id="257" r:id="rId8"/>
-    <p:sldId id="258" r:id="rId9"/>
-    <p:sldId id="259" r:id="rId10"/>
-    <p:sldId id="260" r:id="rId11"/>
-    <p:sldId id="261" r:id="rId12"/>
-    <p:sldId id="262" r:id="rId13"/>
-    <p:sldId id="263" r:id="rId14"/>
-    <p:sldId id="264" r:id="rId15"/>
+    <p:sldId id="256" r:id="rId2"/>
+    <p:sldId id="257" r:id="rId3"/>
+    <p:sldId id="258" r:id="rId4"/>
+    <p:sldId id="259" r:id="rId5"/>
+    <p:sldId id="260" r:id="rId6"/>
+    <p:sldId id="261" r:id="rId7"/>
+    <p:sldId id="262" r:id="rId8"/>
+    <p:sldId id="264" r:id="rId9"/>
   </p:sldIdLst>
-  <p:sldSz cx="12191695" cy="6858000" type="screen4x3"/>
+  <p:sldSz cx="12192000" cy="6858000"/>
   <p:notesSz cx="6858000" cy="9144000"/>
   <p:defaultTextStyle>
     <a:defPPr>
@@ -112,6 +111,22 @@
       </a:defRPr>
     </a:lvl9pPr>
   </p:defaultTextStyle>
+  <p:extLst>
+    <p:ext uri="{EFAFB233-063F-42B5-8137-9DF3F51BA10A}">
+      <p15:sldGuideLst xmlns:p15="http://schemas.microsoft.com/office/powerpoint/2012/main">
+        <p15:guide id="1" orient="horz" pos="2160">
+          <p15:clr>
+            <a:srgbClr val="A4A3A4"/>
+          </p15:clr>
+        </p15:guide>
+        <p15:guide id="2" pos="2880">
+          <p15:clr>
+            <a:srgbClr val="A4A3A4"/>
+          </p15:clr>
+        </p15:guide>
+      </p15:sldGuideLst>
+    </p:ext>
+  </p:extLst>
 </p:presentation>
 </file>
 
@@ -153,10 +168,9 @@
           <a:lstStyle/>
           <a:p>
             <a:r>
-              <a:rPr lang="en-US" smtClean="0"/>
+              <a:rPr lang="en-US"/>
               <a:t>Click to edit Master title style</a:t>
             </a:r>
-            <a:endParaRPr lang="en-US"/>
           </a:p>
         </p:txBody>
       </p:sp>
@@ -272,10 +286,9 @@
           </a:lstStyle>
           <a:p>
             <a:r>
-              <a:rPr lang="en-US" smtClean="0"/>
+              <a:rPr lang="en-US"/>
               <a:t>Click to edit Master subtitle style</a:t>
             </a:r>
-            <a:endParaRPr lang="en-US"/>
           </a:p>
         </p:txBody>
       </p:sp>
@@ -296,7 +309,7 @@
           <a:p>
             <a:fld id="{5BCAD085-E8A6-8845-BD4E-CB4CCA059FC4}" type="datetimeFigureOut">
               <a:rPr lang="en-US" smtClean="0"/>
-              <a:t>1/27/13</a:t>
+              <a:t>8/13/2026</a:t>
             </a:fld>
             <a:endParaRPr lang="en-US"/>
           </a:p>
@@ -390,10 +403,9 @@
           <a:lstStyle/>
           <a:p>
             <a:r>
-              <a:rPr lang="en-US" smtClean="0"/>
+              <a:rPr lang="en-US"/>
               <a:t>Click to edit Master title style</a:t>
             </a:r>
-            <a:endParaRPr lang="en-US"/>
           </a:p>
         </p:txBody>
       </p:sp>
@@ -414,38 +426,37 @@
           <a:p>
             <a:pPr lvl="0"/>
             <a:r>
-              <a:rPr lang="en-US" smtClean="0"/>
+              <a:rPr lang="en-US"/>
               <a:t>Click to edit Master text styles</a:t>
             </a:r>
           </a:p>
           <a:p>
             <a:pPr lvl="1"/>
             <a:r>
-              <a:rPr lang="en-US" smtClean="0"/>
+              <a:rPr lang="en-US"/>
               <a:t>Second level</a:t>
             </a:r>
           </a:p>
           <a:p>
             <a:pPr lvl="2"/>
             <a:r>
-              <a:rPr lang="en-US" smtClean="0"/>
+              <a:rPr lang="en-US"/>
               <a:t>Third level</a:t>
             </a:r>
           </a:p>
           <a:p>
             <a:pPr lvl="3"/>
             <a:r>
-              <a:rPr lang="en-US" smtClean="0"/>
+              <a:rPr lang="en-US"/>
               <a:t>Fourth level</a:t>
             </a:r>
           </a:p>
           <a:p>
             <a:pPr lvl="4"/>
             <a:r>
-              <a:rPr lang="en-US" smtClean="0"/>
+              <a:rPr lang="en-US"/>
               <a:t>Fifth level</a:t>
             </a:r>
-            <a:endParaRPr lang="en-US"/>
           </a:p>
         </p:txBody>
       </p:sp>
@@ -466,7 +477,7 @@
           <a:p>
             <a:fld id="{5BCAD085-E8A6-8845-BD4E-CB4CCA059FC4}" type="datetimeFigureOut">
               <a:rPr lang="en-US" smtClean="0"/>
-              <a:t>1/27/13</a:t>
+              <a:t>8/13/2026</a:t>
             </a:fld>
             <a:endParaRPr lang="en-US"/>
           </a:p>
@@ -565,10 +576,9 @@
           <a:lstStyle/>
           <a:p>
             <a:r>
-              <a:rPr lang="en-US" smtClean="0"/>
+              <a:rPr lang="en-US"/>
               <a:t>Click to edit Master title style</a:t>
             </a:r>
-            <a:endParaRPr lang="en-US"/>
           </a:p>
         </p:txBody>
       </p:sp>
@@ -594,38 +604,37 @@
           <a:p>
             <a:pPr lvl="0"/>
             <a:r>
-              <a:rPr lang="en-US" smtClean="0"/>
+              <a:rPr lang="en-US"/>
               <a:t>Click to edit Master text styles</a:t>
             </a:r>
           </a:p>
           <a:p>
             <a:pPr lvl="1"/>
             <a:r>
-              <a:rPr lang="en-US" smtClean="0"/>
+              <a:rPr lang="en-US"/>
               <a:t>Second level</a:t>
             </a:r>
           </a:p>
           <a:p>
             <a:pPr lvl="2"/>
             <a:r>
-              <a:rPr lang="en-US" smtClean="0"/>
+              <a:rPr lang="en-US"/>
               <a:t>Third level</a:t>
             </a:r>
           </a:p>
           <a:p>
             <a:pPr lvl="3"/>
             <a:r>
-              <a:rPr lang="en-US" smtClean="0"/>
+              <a:rPr lang="en-US"/>
               <a:t>Fourth level</a:t>
             </a:r>
           </a:p>
           <a:p>
             <a:pPr lvl="4"/>
             <a:r>
-              <a:rPr lang="en-US" smtClean="0"/>
+              <a:rPr lang="en-US"/>
               <a:t>Fifth level</a:t>
             </a:r>
-            <a:endParaRPr lang="en-US"/>
           </a:p>
         </p:txBody>
       </p:sp>
@@ -646,7 +655,7 @@
           <a:p>
             <a:fld id="{5BCAD085-E8A6-8845-BD4E-CB4CCA059FC4}" type="datetimeFigureOut">
               <a:rPr lang="en-US" smtClean="0"/>
-              <a:t>1/27/13</a:t>
+              <a:t>8/13/2026</a:t>
             </a:fld>
             <a:endParaRPr lang="en-US"/>
           </a:p>
@@ -740,10 +749,9 @@
           <a:lstStyle/>
           <a:p>
             <a:r>
-              <a:rPr lang="en-US" smtClean="0"/>
+              <a:rPr lang="en-US"/>
               <a:t>Click to edit Master title style</a:t>
             </a:r>
-            <a:endParaRPr lang="en-US"/>
           </a:p>
         </p:txBody>
       </p:sp>
@@ -764,38 +772,37 @@
           <a:p>
             <a:pPr lvl="0"/>
             <a:r>
-              <a:rPr lang="en-US" smtClean="0"/>
+              <a:rPr lang="en-US"/>
               <a:t>Click to edit Master text styles</a:t>
             </a:r>
           </a:p>
           <a:p>
             <a:pPr lvl="1"/>
             <a:r>
-              <a:rPr lang="en-US" smtClean="0"/>
+              <a:rPr lang="en-US"/>
               <a:t>Second level</a:t>
             </a:r>
           </a:p>
           <a:p>
             <a:pPr lvl="2"/>
             <a:r>
-              <a:rPr lang="en-US" smtClean="0"/>
+              <a:rPr lang="en-US"/>
               <a:t>Third level</a:t>
             </a:r>
           </a:p>
           <a:p>
             <a:pPr lvl="3"/>
             <a:r>
-              <a:rPr lang="en-US" smtClean="0"/>
+              <a:rPr lang="en-US"/>
               <a:t>Fourth level</a:t>
             </a:r>
           </a:p>
           <a:p>
             <a:pPr lvl="4"/>
             <a:r>
-              <a:rPr lang="en-US" smtClean="0"/>
+              <a:rPr lang="en-US"/>
               <a:t>Fifth level</a:t>
             </a:r>
-            <a:endParaRPr lang="en-US"/>
           </a:p>
         </p:txBody>
       </p:sp>
@@ -816,7 +823,7 @@
           <a:p>
             <a:fld id="{5BCAD085-E8A6-8845-BD4E-CB4CCA059FC4}" type="datetimeFigureOut">
               <a:rPr lang="en-US" smtClean="0"/>
-              <a:t>1/27/13</a:t>
+              <a:t>8/13/2026</a:t>
             </a:fld>
             <a:endParaRPr lang="en-US"/>
           </a:p>
@@ -919,10 +926,9 @@
           </a:lstStyle>
           <a:p>
             <a:r>
-              <a:rPr lang="en-US" smtClean="0"/>
+              <a:rPr lang="en-US"/>
               <a:t>Click to edit Master title style</a:t>
             </a:r>
-            <a:endParaRPr lang="en-US"/>
           </a:p>
         </p:txBody>
       </p:sp>
@@ -1039,7 +1045,7 @@
           <a:p>
             <a:pPr lvl="0"/>
             <a:r>
-              <a:rPr lang="en-US" smtClean="0"/>
+              <a:rPr lang="en-US"/>
               <a:t>Click to edit Master text styles</a:t>
             </a:r>
           </a:p>
@@ -1062,7 +1068,7 @@
           <a:p>
             <a:fld id="{5BCAD085-E8A6-8845-BD4E-CB4CCA059FC4}" type="datetimeFigureOut">
               <a:rPr lang="en-US" smtClean="0"/>
-              <a:t>1/27/13</a:t>
+              <a:t>8/13/2026</a:t>
             </a:fld>
             <a:endParaRPr lang="en-US"/>
           </a:p>
@@ -1156,10 +1162,9 @@
           <a:lstStyle/>
           <a:p>
             <a:r>
-              <a:rPr lang="en-US" smtClean="0"/>
+              <a:rPr lang="en-US"/>
               <a:t>Click to edit Master title style</a:t>
             </a:r>
-            <a:endParaRPr lang="en-US"/>
           </a:p>
         </p:txBody>
       </p:sp>
@@ -1213,38 +1218,37 @@
           <a:p>
             <a:pPr lvl="0"/>
             <a:r>
-              <a:rPr lang="en-US" smtClean="0"/>
+              <a:rPr lang="en-US"/>
               <a:t>Click to edit Master text styles</a:t>
             </a:r>
           </a:p>
           <a:p>
             <a:pPr lvl="1"/>
             <a:r>
-              <a:rPr lang="en-US" smtClean="0"/>
+              <a:rPr lang="en-US"/>
               <a:t>Second level</a:t>
             </a:r>
           </a:p>
           <a:p>
             <a:pPr lvl="2"/>
             <a:r>
-              <a:rPr lang="en-US" smtClean="0"/>
+              <a:rPr lang="en-US"/>
               <a:t>Third level</a:t>
             </a:r>
           </a:p>
           <a:p>
             <a:pPr lvl="3"/>
             <a:r>
-              <a:rPr lang="en-US" smtClean="0"/>
+              <a:rPr lang="en-US"/>
               <a:t>Fourth level</a:t>
             </a:r>
           </a:p>
           <a:p>
             <a:pPr lvl="4"/>
             <a:r>
-              <a:rPr lang="en-US" smtClean="0"/>
+              <a:rPr lang="en-US"/>
               <a:t>Fifth level</a:t>
             </a:r>
-            <a:endParaRPr lang="en-US"/>
           </a:p>
         </p:txBody>
       </p:sp>
@@ -1298,38 +1302,37 @@
           <a:p>
             <a:pPr lvl="0"/>
             <a:r>
-              <a:rPr lang="en-US" smtClean="0"/>
+              <a:rPr lang="en-US"/>
               <a:t>Click to edit Master text styles</a:t>
             </a:r>
           </a:p>
           <a:p>
             <a:pPr lvl="1"/>
             <a:r>
-              <a:rPr lang="en-US" smtClean="0"/>
+              <a:rPr lang="en-US"/>
               <a:t>Second level</a:t>
             </a:r>
           </a:p>
           <a:p>
             <a:pPr lvl="2"/>
             <a:r>
-              <a:rPr lang="en-US" smtClean="0"/>
+              <a:rPr lang="en-US"/>
               <a:t>Third level</a:t>
             </a:r>
           </a:p>
           <a:p>
             <a:pPr lvl="3"/>
             <a:r>
-              <a:rPr lang="en-US" smtClean="0"/>
+              <a:rPr lang="en-US"/>
               <a:t>Fourth level</a:t>
             </a:r>
           </a:p>
           <a:p>
             <a:pPr lvl="4"/>
             <a:r>
-              <a:rPr lang="en-US" smtClean="0"/>
+              <a:rPr lang="en-US"/>
               <a:t>Fifth level</a:t>
             </a:r>
-            <a:endParaRPr lang="en-US"/>
           </a:p>
         </p:txBody>
       </p:sp>
@@ -1350,7 +1353,7 @@
           <a:p>
             <a:fld id="{5BCAD085-E8A6-8845-BD4E-CB4CCA059FC4}" type="datetimeFigureOut">
               <a:rPr lang="en-US" smtClean="0"/>
-              <a:t>1/27/13</a:t>
+              <a:t>8/13/2026</a:t>
             </a:fld>
             <a:endParaRPr lang="en-US"/>
           </a:p>
@@ -1448,10 +1451,9 @@
           </a:lstStyle>
           <a:p>
             <a:r>
-              <a:rPr lang="en-US" smtClean="0"/>
+              <a:rPr lang="en-US"/>
               <a:t>Click to edit Master title style</a:t>
             </a:r>
-            <a:endParaRPr lang="en-US"/>
           </a:p>
         </p:txBody>
       </p:sp>
@@ -1514,7 +1516,7 @@
           <a:p>
             <a:pPr lvl="0"/>
             <a:r>
-              <a:rPr lang="en-US" smtClean="0"/>
+              <a:rPr lang="en-US"/>
               <a:t>Click to edit Master text styles</a:t>
             </a:r>
           </a:p>
@@ -1570,38 +1572,37 @@
           <a:p>
             <a:pPr lvl="0"/>
             <a:r>
-              <a:rPr lang="en-US" smtClean="0"/>
+              <a:rPr lang="en-US"/>
               <a:t>Click to edit Master text styles</a:t>
             </a:r>
           </a:p>
           <a:p>
             <a:pPr lvl="1"/>
             <a:r>
-              <a:rPr lang="en-US" smtClean="0"/>
+              <a:rPr lang="en-US"/>
               <a:t>Second level</a:t>
             </a:r>
           </a:p>
           <a:p>
             <a:pPr lvl="2"/>
             <a:r>
-              <a:rPr lang="en-US" smtClean="0"/>
+              <a:rPr lang="en-US"/>
               <a:t>Third level</a:t>
             </a:r>
           </a:p>
           <a:p>
             <a:pPr lvl="3"/>
             <a:r>
-              <a:rPr lang="en-US" smtClean="0"/>
+              <a:rPr lang="en-US"/>
               <a:t>Fourth level</a:t>
             </a:r>
           </a:p>
           <a:p>
             <a:pPr lvl="4"/>
             <a:r>
-              <a:rPr lang="en-US" smtClean="0"/>
+              <a:rPr lang="en-US"/>
               <a:t>Fifth level</a:t>
             </a:r>
-            <a:endParaRPr lang="en-US"/>
           </a:p>
         </p:txBody>
       </p:sp>
@@ -1664,7 +1665,7 @@
           <a:p>
             <a:pPr lvl="0"/>
             <a:r>
-              <a:rPr lang="en-US" smtClean="0"/>
+              <a:rPr lang="en-US"/>
               <a:t>Click to edit Master text styles</a:t>
             </a:r>
           </a:p>
@@ -1720,38 +1721,37 @@
           <a:p>
             <a:pPr lvl="0"/>
             <a:r>
-              <a:rPr lang="en-US" smtClean="0"/>
+              <a:rPr lang="en-US"/>
               <a:t>Click to edit Master text styles</a:t>
             </a:r>
           </a:p>
           <a:p>
             <a:pPr lvl="1"/>
             <a:r>
-              <a:rPr lang="en-US" smtClean="0"/>
+              <a:rPr lang="en-US"/>
               <a:t>Second level</a:t>
             </a:r>
           </a:p>
           <a:p>
             <a:pPr lvl="2"/>
             <a:r>
-              <a:rPr lang="en-US" smtClean="0"/>
+              <a:rPr lang="en-US"/>
               <a:t>Third level</a:t>
             </a:r>
           </a:p>
           <a:p>
             <a:pPr lvl="3"/>
             <a:r>
-              <a:rPr lang="en-US" smtClean="0"/>
+              <a:rPr lang="en-US"/>
               <a:t>Fourth level</a:t>
             </a:r>
           </a:p>
           <a:p>
             <a:pPr lvl="4"/>
             <a:r>
-              <a:rPr lang="en-US" smtClean="0"/>
+              <a:rPr lang="en-US"/>
               <a:t>Fifth level</a:t>
             </a:r>
-            <a:endParaRPr lang="en-US"/>
           </a:p>
         </p:txBody>
       </p:sp>
@@ -1772,7 +1772,7 @@
           <a:p>
             <a:fld id="{5BCAD085-E8A6-8845-BD4E-CB4CCA059FC4}" type="datetimeFigureOut">
               <a:rPr lang="en-US" smtClean="0"/>
-              <a:t>1/27/13</a:t>
+              <a:t>8/13/2026</a:t>
             </a:fld>
             <a:endParaRPr lang="en-US"/>
           </a:p>
@@ -1866,10 +1866,9 @@
           <a:lstStyle/>
           <a:p>
             <a:r>
-              <a:rPr lang="en-US" smtClean="0"/>
+              <a:rPr lang="en-US"/>
               <a:t>Click to edit Master title style</a:t>
             </a:r>
-            <a:endParaRPr lang="en-US"/>
           </a:p>
         </p:txBody>
       </p:sp>
@@ -1890,7 +1889,7 @@
           <a:p>
             <a:fld id="{5BCAD085-E8A6-8845-BD4E-CB4CCA059FC4}" type="datetimeFigureOut">
               <a:rPr lang="en-US" smtClean="0"/>
-              <a:t>1/27/13</a:t>
+              <a:t>8/13/2026</a:t>
             </a:fld>
             <a:endParaRPr lang="en-US"/>
           </a:p>
@@ -1985,7 +1984,7 @@
           <a:p>
             <a:fld id="{5BCAD085-E8A6-8845-BD4E-CB4CCA059FC4}" type="datetimeFigureOut">
               <a:rPr lang="en-US" smtClean="0"/>
-              <a:t>1/27/13</a:t>
+              <a:t>8/13/2026</a:t>
             </a:fld>
             <a:endParaRPr lang="en-US"/>
           </a:p>
@@ -2088,10 +2087,9 @@
           </a:lstStyle>
           <a:p>
             <a:r>
-              <a:rPr lang="en-US" smtClean="0"/>
+              <a:rPr lang="en-US"/>
               <a:t>Click to edit Master title style</a:t>
             </a:r>
-            <a:endParaRPr lang="en-US"/>
           </a:p>
         </p:txBody>
       </p:sp>
@@ -2145,38 +2143,37 @@
           <a:p>
             <a:pPr lvl="0"/>
             <a:r>
-              <a:rPr lang="en-US" smtClean="0"/>
+              <a:rPr lang="en-US"/>
               <a:t>Click to edit Master text styles</a:t>
             </a:r>
           </a:p>
           <a:p>
             <a:pPr lvl="1"/>
             <a:r>
-              <a:rPr lang="en-US" smtClean="0"/>
+              <a:rPr lang="en-US"/>
               <a:t>Second level</a:t>
             </a:r>
           </a:p>
           <a:p>
             <a:pPr lvl="2"/>
             <a:r>
-              <a:rPr lang="en-US" smtClean="0"/>
+              <a:rPr lang="en-US"/>
               <a:t>Third level</a:t>
             </a:r>
           </a:p>
           <a:p>
             <a:pPr lvl="3"/>
             <a:r>
-              <a:rPr lang="en-US" smtClean="0"/>
+              <a:rPr lang="en-US"/>
               <a:t>Fourth level</a:t>
             </a:r>
           </a:p>
           <a:p>
             <a:pPr lvl="4"/>
             <a:r>
-              <a:rPr lang="en-US" smtClean="0"/>
+              <a:rPr lang="en-US"/>
               <a:t>Fifth level</a:t>
             </a:r>
-            <a:endParaRPr lang="en-US"/>
           </a:p>
         </p:txBody>
       </p:sp>
@@ -2239,7 +2236,7 @@
           <a:p>
             <a:pPr lvl="0"/>
             <a:r>
-              <a:rPr lang="en-US" smtClean="0"/>
+              <a:rPr lang="en-US"/>
               <a:t>Click to edit Master text styles</a:t>
             </a:r>
           </a:p>
@@ -2262,7 +2259,7 @@
           <a:p>
             <a:fld id="{5BCAD085-E8A6-8845-BD4E-CB4CCA059FC4}" type="datetimeFigureOut">
               <a:rPr lang="en-US" smtClean="0"/>
-              <a:t>1/27/13</a:t>
+              <a:t>8/13/2026</a:t>
             </a:fld>
             <a:endParaRPr lang="en-US"/>
           </a:p>
@@ -2365,10 +2362,9 @@
           </a:lstStyle>
           <a:p>
             <a:r>
-              <a:rPr lang="en-US" smtClean="0"/>
+              <a:rPr lang="en-US"/>
               <a:t>Click to edit Master title style</a:t>
             </a:r>
-            <a:endParaRPr lang="en-US"/>
           </a:p>
         </p:txBody>
       </p:sp>
@@ -2492,7 +2488,7 @@
           <a:p>
             <a:pPr lvl="0"/>
             <a:r>
-              <a:rPr lang="en-US" smtClean="0"/>
+              <a:rPr lang="en-US"/>
               <a:t>Click to edit Master text styles</a:t>
             </a:r>
           </a:p>
@@ -2515,7 +2511,7 @@
           <a:p>
             <a:fld id="{5BCAD085-E8A6-8845-BD4E-CB4CCA059FC4}" type="datetimeFigureOut">
               <a:rPr lang="en-US" smtClean="0"/>
-              <a:t>1/27/13</a:t>
+              <a:t>8/13/2026</a:t>
             </a:fld>
             <a:endParaRPr lang="en-US"/>
           </a:p>
@@ -2624,10 +2620,9 @@
           <a:lstStyle/>
           <a:p>
             <a:r>
-              <a:rPr lang="en-US" smtClean="0"/>
+              <a:rPr lang="en-US"/>
               <a:t>Click to edit Master title style</a:t>
             </a:r>
-            <a:endParaRPr lang="en-US"/>
           </a:p>
         </p:txBody>
       </p:sp>
@@ -2658,38 +2653,37 @@
           <a:p>
             <a:pPr lvl="0"/>
             <a:r>
-              <a:rPr lang="en-US" smtClean="0"/>
+              <a:rPr lang="en-US"/>
               <a:t>Click to edit Master text styles</a:t>
             </a:r>
           </a:p>
           <a:p>
             <a:pPr lvl="1"/>
             <a:r>
-              <a:rPr lang="en-US" smtClean="0"/>
+              <a:rPr lang="en-US"/>
               <a:t>Second level</a:t>
             </a:r>
           </a:p>
           <a:p>
             <a:pPr lvl="2"/>
             <a:r>
-              <a:rPr lang="en-US" smtClean="0"/>
+              <a:rPr lang="en-US"/>
               <a:t>Third level</a:t>
             </a:r>
           </a:p>
           <a:p>
             <a:pPr lvl="3"/>
             <a:r>
-              <a:rPr lang="en-US" smtClean="0"/>
+              <a:rPr lang="en-US"/>
               <a:t>Fourth level</a:t>
             </a:r>
           </a:p>
           <a:p>
             <a:pPr lvl="4"/>
             <a:r>
-              <a:rPr lang="en-US" smtClean="0"/>
+              <a:rPr lang="en-US"/>
               <a:t>Fifth level</a:t>
             </a:r>
-            <a:endParaRPr lang="en-US"/>
           </a:p>
         </p:txBody>
       </p:sp>
@@ -2728,7 +2722,7 @@
           <a:p>
             <a:fld id="{5BCAD085-E8A6-8845-BD4E-CB4CCA059FC4}" type="datetimeFigureOut">
               <a:rPr lang="en-US" smtClean="0"/>
-              <a:t>1/27/13</a:t>
+              <a:t>8/13/2026</a:t>
             </a:fld>
             <a:endParaRPr lang="en-US"/>
           </a:p>
@@ -3087,7 +3081,7 @@
 </file>
 
 <file path=ppt/slides/slide1.xml><?xml version="1.0" encoding="utf-8"?>
-<p:sld xmlns:a="http://schemas.openxmlformats.org/drawingml/2006/main" xmlns:p="http://schemas.openxmlformats.org/presentationml/2006/main" xmlns:r="http://schemas.openxmlformats.org/officeDocument/2006/relationships">
+<p:sld xmlns:a="http://schemas.openxmlformats.org/drawingml/2006/main" xmlns:r="http://schemas.openxmlformats.org/officeDocument/2006/relationships" xmlns:p="http://schemas.openxmlformats.org/presentationml/2006/main">
   <p:cSld>
     <p:spTree>
       <p:nvGrpSpPr>
@@ -3095,7 +3089,14 @@
         <p:cNvGrpSpPr/>
         <p:nvPr/>
       </p:nvGrpSpPr>
-      <p:grpSpPr/>
+      <p:grpSpPr>
+        <a:xfrm>
+          <a:off x="0" y="0"/>
+          <a:ext cx="0" cy="0"/>
+          <a:chOff x="0" y="0"/>
+          <a:chExt cx="0" cy="0"/>
+        </a:xfrm>
+      </p:grpSpPr>
       <p:sp>
         <p:nvSpPr>
           <p:cNvPr id="2" name="Rectangle 1"/>
@@ -3104,7 +3105,7 @@
         </p:nvSpPr>
         <p:spPr>
           <a:xfrm>
-            <a:off x="0" y="0"/>
+            <a:off x="305" y="-141889"/>
             <a:ext cx="12191695" cy="6858000"/>
           </a:xfrm>
           <a:prstGeom prst="rect">
@@ -3136,6 +3137,7 @@
           <a:lstStyle/>
           <a:p>
             <a:pPr algn="ctr"/>
+            <a:endParaRPr/>
           </a:p>
         </p:txBody>
       </p:sp>
@@ -3147,8 +3149,8 @@
         </p:nvSpPr>
         <p:spPr>
           <a:xfrm>
-            <a:off x="731520" y="1371600"/>
-            <a:ext cx="3840480" cy="365760"/>
+            <a:off x="731520" y="1111469"/>
+            <a:ext cx="4274032" cy="625891"/>
           </a:xfrm>
           <a:prstGeom prst="roundRect">
             <a:avLst/>
@@ -3187,6 +3189,7 @@
               </a:defRPr>
             </a:pPr>
             <a:r>
+              <a:rPr sz="1200" dirty="0"/>
               <a:t>SEMICONDUCTOR TOOLING ALGORITHMS</a:t>
             </a:r>
           </a:p>
@@ -3201,7 +3204,7 @@
         <p:spPr>
           <a:xfrm>
             <a:off x="731520" y="2011680"/>
-            <a:ext cx="10515600" cy="1645920"/>
+            <a:ext cx="10515600" cy="1364476"/>
           </a:xfrm>
           <a:prstGeom prst="rect">
             <a:avLst/>
@@ -3223,6 +3226,7 @@
               </a:defRPr>
             </a:pPr>
             <a:r>
+              <a:rPr dirty="0"/>
               <a:t>Drift-Sense</a:t>
             </a:r>
           </a:p>
@@ -3239,6 +3243,7 @@
               </a:defRPr>
             </a:pPr>
             <a:r>
+              <a:rPr b="1" dirty="0"/>
               <a:t>Navigation-Error Recovery &amp; Sub-Pixel Alignment for Wafer Inspection Tools</a:t>
             </a:r>
           </a:p>
@@ -3286,6 +3291,7 @@
           <a:lstStyle/>
           <a:p>
             <a:pPr algn="ctr"/>
+            <a:endParaRPr/>
           </a:p>
         </p:txBody>
       </p:sp>
@@ -3297,8 +3303,8 @@
         </p:nvSpPr>
         <p:spPr>
           <a:xfrm>
-            <a:off x="1005840" y="4297680"/>
-            <a:ext cx="10149840" cy="1645920"/>
+            <a:off x="1020927" y="4564077"/>
+            <a:ext cx="10149840" cy="1113125"/>
           </a:xfrm>
           <a:prstGeom prst="rect">
             <a:avLst/>
@@ -3323,6 +3329,7 @@
               </a:defRPr>
             </a:pPr>
             <a:r>
+              <a:rPr dirty="0"/>
               <a:t>PROJECT CORE DELIVERABLES &amp; TEAM ROLES</a:t>
             </a:r>
           </a:p>
@@ -3338,7 +3345,24 @@
               </a:defRPr>
             </a:pPr>
             <a:r>
-              <a:t>• Member B (Algorithmic Lead): Preprocessing (CLAHE), Pyramidal Multi-Scale Search, NMS Peak Extraction, Periodicity Tie-Breaking, Sub-Pixel Parabolic Fitting, ORB+RANSAC AI Fallback, and Technical Documentation.</a:t>
+              <a:rPr dirty="0"/>
+              <a:t>• </a:t>
+            </a:r>
+            <a:r>
+              <a:rPr lang="en-US" dirty="0"/>
+              <a:t>Krish Deshpande </a:t>
+            </a:r>
+            <a:r>
+              <a:rPr dirty="0"/>
+              <a:t>(Algorithmic Lead): Preprocessing (CLAHE), Pyramidal Multi-Scale Search, NMS Peak Extraction, Periodicity Tie-Breaking, Sub-</a:t>
+            </a:r>
+            <a:r>
+              <a:rPr lang="en-US" dirty="0"/>
+              <a:t>     </a:t>
+            </a:r>
+            <a:r>
+              <a:rPr dirty="0"/>
+              <a:t>Pixel Parabolic Fitting, ORB+RANSAC AI Fallback, and Technical Documentation.</a:t>
             </a:r>
           </a:p>
           <a:p>
@@ -3350,7 +3374,28 @@
               </a:defRPr>
             </a:pPr>
             <a:r>
-              <a:t>• Shubh (Data &amp; Evaluation): Synthetic Ground-Truth Data Pipeline, Metrics CSV Generation, Visualization Overlays &amp; Repository Setup.</a:t>
+              <a:rPr dirty="0">
+                <a:solidFill>
+                  <a:schemeClr val="bg1"/>
+                </a:solidFill>
+              </a:rPr>
+              <a:t>• Shubh </a:t>
+            </a:r>
+            <a:r>
+              <a:rPr lang="en-US" dirty="0">
+                <a:solidFill>
+                  <a:schemeClr val="bg1"/>
+                </a:solidFill>
+              </a:rPr>
+              <a:t>Garg </a:t>
+            </a:r>
+            <a:r>
+              <a:rPr dirty="0">
+                <a:solidFill>
+                  <a:schemeClr val="bg1"/>
+                </a:solidFill>
+              </a:rPr>
+              <a:t>(Data &amp; Evaluation): Synthetic Ground-Truth Data Pipeline, Metrics CSV Generation, Visualization Overlays &amp; Repository Setup.</a:t>
             </a:r>
           </a:p>
         </p:txBody>
@@ -3364,7 +3409,7 @@
 </file>
 
 <file path=ppt/slides/slide2.xml><?xml version="1.0" encoding="utf-8"?>
-<p:sld xmlns:a="http://schemas.openxmlformats.org/drawingml/2006/main" xmlns:p="http://schemas.openxmlformats.org/presentationml/2006/main" xmlns:r="http://schemas.openxmlformats.org/officeDocument/2006/relationships">
+<p:sld xmlns:a="http://schemas.openxmlformats.org/drawingml/2006/main" xmlns:r="http://schemas.openxmlformats.org/officeDocument/2006/relationships" xmlns:p="http://schemas.openxmlformats.org/presentationml/2006/main">
   <p:cSld>
     <p:spTree>
       <p:nvGrpSpPr>
@@ -3372,7 +3417,14 @@
         <p:cNvGrpSpPr/>
         <p:nvPr/>
       </p:nvGrpSpPr>
-      <p:grpSpPr/>
+      <p:grpSpPr>
+        <a:xfrm>
+          <a:off x="0" y="0"/>
+          <a:ext cx="0" cy="0"/>
+          <a:chOff x="0" y="0"/>
+          <a:chExt cx="0" cy="0"/>
+        </a:xfrm>
+      </p:grpSpPr>
       <p:sp>
         <p:nvSpPr>
           <p:cNvPr id="2" name="Rectangle 1"/>
@@ -3413,6 +3465,7 @@
           <a:lstStyle/>
           <a:p>
             <a:pPr algn="ctr"/>
+            <a:endParaRPr dirty="0"/>
           </a:p>
         </p:txBody>
       </p:sp>
@@ -3424,8 +3477,8 @@
         </p:nvSpPr>
         <p:spPr>
           <a:xfrm>
-            <a:off x="731520" y="365760"/>
-            <a:ext cx="9144000" cy="365760"/>
+            <a:off x="731520" y="431135"/>
+            <a:ext cx="9144000" cy="276999"/>
           </a:xfrm>
           <a:prstGeom prst="rect">
             <a:avLst/>
@@ -3447,6 +3500,7 @@
               </a:defRPr>
             </a:pPr>
             <a:r>
+              <a:rPr sz="1200" dirty="0"/>
               <a:t>DRIFT-SENSE / SEMICONDUCTOR ALGORITHMIC TOOLING</a:t>
             </a:r>
           </a:p>
@@ -3460,7 +3514,7 @@
         </p:nvSpPr>
         <p:spPr>
           <a:xfrm>
-            <a:off x="731520" y="640080"/>
+            <a:off x="731520" y="795528"/>
             <a:ext cx="10515600" cy="731520"/>
           </a:xfrm>
           <a:prstGeom prst="rect">
@@ -3483,6 +3537,7 @@
               </a:defRPr>
             </a:pPr>
             <a:r>
+              <a:rPr dirty="0"/>
               <a:t>Industry Challenge: Stage Drift in Wafer Inspection</a:t>
             </a:r>
           </a:p>
@@ -3530,6 +3585,7 @@
           <a:lstStyle/>
           <a:p>
             <a:pPr algn="ctr"/>
+            <a:endParaRPr/>
           </a:p>
         </p:txBody>
       </p:sp>
@@ -3573,6 +3629,7 @@
           <a:lstStyle/>
           <a:p>
             <a:pPr algn="ctr"/>
+            <a:endParaRPr/>
           </a:p>
         </p:txBody>
       </p:sp>
@@ -3585,7 +3642,7 @@
         <p:spPr>
           <a:xfrm>
             <a:off x="914400" y="1783080"/>
-            <a:ext cx="2962656" cy="4297680"/>
+            <a:ext cx="2962656" cy="3390672"/>
           </a:xfrm>
           <a:prstGeom prst="rect">
             <a:avLst/>
@@ -3610,6 +3667,7 @@
               </a:defRPr>
             </a:pPr>
             <a:r>
+              <a:rPr dirty="0"/>
               <a:t>1. Mechanical Drift</a:t>
             </a:r>
           </a:p>
@@ -3620,7 +3678,7 @@
               </a:spcAft>
             </a:pPr>
             <a:r>
-              <a:rPr b="1" sz="1200">
+              <a:rPr b="1" dirty="0">
                 <a:solidFill>
                   <a:srgbClr val="F8FAFC"/>
                 </a:solidFill>
@@ -3628,7 +3686,7 @@
               <a:t>• Stage Hysteresis: </a:t>
             </a:r>
             <a:r>
-              <a:rPr sz="1200">
+              <a:rPr dirty="0">
                 <a:solidFill>
                   <a:srgbClr val="94A3B8"/>
                 </a:solidFill>
@@ -3643,7 +3701,7 @@
               </a:spcAft>
             </a:pPr>
             <a:r>
-              <a:rPr b="1" sz="1200">
+              <a:rPr b="1" dirty="0">
                 <a:solidFill>
                   <a:srgbClr val="F8FAFC"/>
                 </a:solidFill>
@@ -3651,7 +3709,7 @@
               <a:t>• Thermal Shifts: </a:t>
             </a:r>
             <a:r>
-              <a:rPr sz="1200">
+              <a:rPr dirty="0">
                 <a:solidFill>
                   <a:srgbClr val="94A3B8"/>
                 </a:solidFill>
@@ -3666,7 +3724,7 @@
               </a:spcAft>
             </a:pPr>
             <a:r>
-              <a:rPr b="1" sz="1200">
+              <a:rPr b="1" dirty="0">
                 <a:solidFill>
                   <a:srgbClr val="F8FAFC"/>
                 </a:solidFill>
@@ -3674,7 +3732,7 @@
               <a:t>• Position Drift: </a:t>
             </a:r>
             <a:r>
-              <a:rPr sz="1200">
+              <a:rPr dirty="0">
                 <a:solidFill>
                   <a:srgbClr val="94A3B8"/>
                 </a:solidFill>
@@ -3726,6 +3784,7 @@
           <a:lstStyle/>
           <a:p>
             <a:pPr algn="ctr"/>
+            <a:endParaRPr/>
           </a:p>
         </p:txBody>
       </p:sp>
@@ -3769,6 +3828,7 @@
           <a:lstStyle/>
           <a:p>
             <a:pPr algn="ctr"/>
+            <a:endParaRPr/>
           </a:p>
         </p:txBody>
       </p:sp>
@@ -3781,7 +3841,7 @@
         <p:spPr>
           <a:xfrm>
             <a:off x="4608576" y="1783080"/>
-            <a:ext cx="2962656" cy="4297680"/>
+            <a:ext cx="2962656" cy="3082895"/>
           </a:xfrm>
           <a:prstGeom prst="rect">
             <a:avLst/>
@@ -3806,6 +3866,7 @@
               </a:defRPr>
             </a:pPr>
             <a:r>
+              <a:rPr sz="1600" dirty="0"/>
               <a:t>2. Optical Ambiguity</a:t>
             </a:r>
           </a:p>
@@ -3816,7 +3877,7 @@
               </a:spcAft>
             </a:pPr>
             <a:r>
-              <a:rPr b="1" sz="1200">
+              <a:rPr sz="1600" b="1" dirty="0">
                 <a:solidFill>
                   <a:srgbClr val="F8FAFC"/>
                 </a:solidFill>
@@ -3824,7 +3885,7 @@
               <a:t>• High Periodicity: </a:t>
             </a:r>
             <a:r>
-              <a:rPr sz="1200">
+              <a:rPr sz="1600" dirty="0">
                 <a:solidFill>
                   <a:srgbClr val="94A3B8"/>
                 </a:solidFill>
@@ -3839,7 +3900,7 @@
               </a:spcAft>
             </a:pPr>
             <a:r>
-              <a:rPr b="1" sz="1200">
+              <a:rPr sz="1600" b="1" dirty="0">
                 <a:solidFill>
                   <a:srgbClr val="F8FAFC"/>
                 </a:solidFill>
@@ -3847,7 +3908,7 @@
               <a:t>• Low Contrast: </a:t>
             </a:r>
             <a:r>
-              <a:rPr sz="1200">
+              <a:rPr sz="1600" dirty="0">
                 <a:solidFill>
                   <a:srgbClr val="94A3B8"/>
                 </a:solidFill>
@@ -3862,7 +3923,7 @@
               </a:spcAft>
             </a:pPr>
             <a:r>
-              <a:rPr b="1" sz="1200">
+              <a:rPr sz="1600" b="1" dirty="0">
                 <a:solidFill>
                   <a:srgbClr val="F8FAFC"/>
                 </a:solidFill>
@@ -3870,7 +3931,7 @@
               <a:t>• Illumination Noise: </a:t>
             </a:r>
             <a:r>
-              <a:rPr sz="1200">
+              <a:rPr sz="1600" dirty="0">
                 <a:solidFill>
                   <a:srgbClr val="94A3B8"/>
                 </a:solidFill>
@@ -3922,6 +3983,7 @@
           <a:lstStyle/>
           <a:p>
             <a:pPr algn="ctr"/>
+            <a:endParaRPr/>
           </a:p>
         </p:txBody>
       </p:sp>
@@ -3965,6 +4027,7 @@
           <a:lstStyle/>
           <a:p>
             <a:pPr algn="ctr"/>
+            <a:endParaRPr/>
           </a:p>
         </p:txBody>
       </p:sp>
@@ -3977,7 +4040,7 @@
         <p:spPr>
           <a:xfrm>
             <a:off x="8302752" y="1783080"/>
-            <a:ext cx="2962656" cy="4297680"/>
+            <a:ext cx="2962656" cy="3082895"/>
           </a:xfrm>
           <a:prstGeom prst="rect">
             <a:avLst/>
@@ -4002,6 +4065,7 @@
               </a:defRPr>
             </a:pPr>
             <a:r>
+              <a:rPr sz="1600" dirty="0"/>
               <a:t>3. Technical Solution</a:t>
             </a:r>
           </a:p>
@@ -4012,7 +4076,7 @@
               </a:spcAft>
             </a:pPr>
             <a:r>
-              <a:rPr b="1" sz="1200">
+              <a:rPr sz="1600" b="1" dirty="0">
                 <a:solidFill>
                   <a:srgbClr val="F8FAFC"/>
                 </a:solidFill>
@@ -4020,7 +4084,7 @@
               <a:t>• Drift-Sense Engine: </a:t>
             </a:r>
             <a:r>
-              <a:rPr sz="1200">
+              <a:rPr sz="1600" dirty="0">
                 <a:solidFill>
                   <a:srgbClr val="94A3B8"/>
                 </a:solidFill>
@@ -4035,7 +4099,7 @@
               </a:spcAft>
             </a:pPr>
             <a:r>
-              <a:rPr b="1" sz="1200">
+              <a:rPr sz="1600" b="1" dirty="0">
                 <a:solidFill>
                   <a:srgbClr val="F8FAFC"/>
                 </a:solidFill>
@@ -4043,7 +4107,7 @@
               <a:t>• Nanometer Precision: </a:t>
             </a:r>
             <a:r>
-              <a:rPr sz="1200">
+              <a:rPr sz="1600" dirty="0">
                 <a:solidFill>
                   <a:srgbClr val="94A3B8"/>
                 </a:solidFill>
@@ -4058,7 +4122,7 @@
               </a:spcAft>
             </a:pPr>
             <a:r>
-              <a:rPr b="1" sz="1200">
+              <a:rPr sz="1600" b="1" dirty="0">
                 <a:solidFill>
                   <a:srgbClr val="F8FAFC"/>
                 </a:solidFill>
@@ -4066,7 +4130,7 @@
               <a:t>• Scale Resilient: </a:t>
             </a:r>
             <a:r>
-              <a:rPr sz="1200">
+              <a:rPr sz="1600" dirty="0">
                 <a:solidFill>
                   <a:srgbClr val="94A3B8"/>
                 </a:solidFill>
@@ -4085,7 +4149,7 @@
 </file>
 
 <file path=ppt/slides/slide3.xml><?xml version="1.0" encoding="utf-8"?>
-<p:sld xmlns:a="http://schemas.openxmlformats.org/drawingml/2006/main" xmlns:p="http://schemas.openxmlformats.org/presentationml/2006/main" xmlns:r="http://schemas.openxmlformats.org/officeDocument/2006/relationships">
+<p:sld xmlns:a="http://schemas.openxmlformats.org/drawingml/2006/main" xmlns:r="http://schemas.openxmlformats.org/officeDocument/2006/relationships" xmlns:p="http://schemas.openxmlformats.org/presentationml/2006/main">
   <p:cSld>
     <p:spTree>
       <p:nvGrpSpPr>
@@ -4093,7 +4157,14 @@
         <p:cNvGrpSpPr/>
         <p:nvPr/>
       </p:nvGrpSpPr>
-      <p:grpSpPr/>
+      <p:grpSpPr>
+        <a:xfrm>
+          <a:off x="0" y="0"/>
+          <a:ext cx="0" cy="0"/>
+          <a:chOff x="0" y="0"/>
+          <a:chExt cx="0" cy="0"/>
+        </a:xfrm>
+      </p:grpSpPr>
       <p:sp>
         <p:nvSpPr>
           <p:cNvPr id="2" name="Rectangle 1"/>
@@ -4134,6 +4205,7 @@
           <a:lstStyle/>
           <a:p>
             <a:pPr algn="ctr"/>
+            <a:endParaRPr/>
           </a:p>
         </p:txBody>
       </p:sp>
@@ -4145,8 +4217,8 @@
         </p:nvSpPr>
         <p:spPr>
           <a:xfrm>
-            <a:off x="731520" y="365760"/>
-            <a:ext cx="9144000" cy="365760"/>
+            <a:off x="731520" y="457200"/>
+            <a:ext cx="9144000" cy="276999"/>
           </a:xfrm>
           <a:prstGeom prst="rect">
             <a:avLst/>
@@ -4168,6 +4240,7 @@
               </a:defRPr>
             </a:pPr>
             <a:r>
+              <a:rPr sz="1200" dirty="0"/>
               <a:t>DRIFT-SENSE / SEMICONDUCTOR ALGORITHMIC TOOLING</a:t>
             </a:r>
           </a:p>
@@ -4181,7 +4254,7 @@
         </p:nvSpPr>
         <p:spPr>
           <a:xfrm>
-            <a:off x="731520" y="640080"/>
+            <a:off x="731520" y="822960"/>
             <a:ext cx="10515600" cy="731520"/>
           </a:xfrm>
           <a:prstGeom prst="rect">
@@ -4204,6 +4277,7 @@
               </a:defRPr>
             </a:pPr>
             <a:r>
+              <a:rPr dirty="0"/>
               <a:t>System Architecture &amp; Processing Pipeline</a:t>
             </a:r>
           </a:p>
@@ -4251,6 +4325,7 @@
           <a:lstStyle/>
           <a:p>
             <a:pPr algn="ctr"/>
+            <a:endParaRPr/>
           </a:p>
         </p:txBody>
       </p:sp>
@@ -4294,6 +4369,7 @@
           <a:lstStyle/>
           <a:p>
             <a:pPr algn="ctr"/>
+            <a:endParaRPr/>
           </a:p>
         </p:txBody>
       </p:sp>
@@ -4306,7 +4382,7 @@
         <p:spPr>
           <a:xfrm>
             <a:off x="914400" y="1783080"/>
-            <a:ext cx="2176272" cy="4297680"/>
+            <a:ext cx="2176272" cy="3406061"/>
           </a:xfrm>
           <a:prstGeom prst="rect">
             <a:avLst/>
@@ -4331,6 +4407,7 @@
               </a:defRPr>
             </a:pPr>
             <a:r>
+              <a:rPr sz="1600" dirty="0"/>
               <a:t>STEP 1: PREPROCESS</a:t>
             </a:r>
           </a:p>
@@ -4341,7 +4418,7 @@
               </a:spcAft>
             </a:pPr>
             <a:r>
-              <a:rPr b="1" sz="1200">
+              <a:rPr sz="1600" b="1" dirty="0">
                 <a:solidFill>
                   <a:srgbClr val="F8FAFC"/>
                 </a:solidFill>
@@ -4349,7 +4426,7 @@
               <a:t>• Input Capture: </a:t>
             </a:r>
             <a:r>
-              <a:rPr sz="1200">
+              <a:rPr sz="1600" dirty="0">
                 <a:solidFill>
                   <a:srgbClr val="94A3B8"/>
                 </a:solidFill>
@@ -4364,7 +4441,7 @@
               </a:spcAft>
             </a:pPr>
             <a:r>
-              <a:rPr b="1" sz="1200">
+              <a:rPr sz="1600" b="1" dirty="0">
                 <a:solidFill>
                   <a:srgbClr val="F8FAFC"/>
                 </a:solidFill>
@@ -4372,7 +4449,7 @@
               <a:t>• Adaptive CLAHE: </a:t>
             </a:r>
             <a:r>
-              <a:rPr sz="1200">
+              <a:rPr sz="1600" dirty="0">
                 <a:solidFill>
                   <a:srgbClr val="94A3B8"/>
                 </a:solidFill>
@@ -4387,7 +4464,7 @@
               </a:spcAft>
             </a:pPr>
             <a:r>
-              <a:rPr b="1" sz="1200">
+              <a:rPr sz="1600" b="1" dirty="0">
                 <a:solidFill>
                   <a:srgbClr val="F8FAFC"/>
                 </a:solidFill>
@@ -4395,7 +4472,7 @@
               <a:t>• Gaussian Blur: </a:t>
             </a:r>
             <a:r>
-              <a:rPr sz="1200">
+              <a:rPr sz="1600" dirty="0">
                 <a:solidFill>
                   <a:srgbClr val="94A3B8"/>
                 </a:solidFill>
@@ -4410,7 +4487,7 @@
               </a:spcAft>
             </a:pPr>
             <a:r>
-              <a:rPr b="1" sz="1200">
+              <a:rPr sz="1600" b="1" dirty="0">
                 <a:solidFill>
                   <a:srgbClr val="F8FAFC"/>
                 </a:solidFill>
@@ -4418,7 +4495,7 @@
               <a:t>• Sobel Edges: </a:t>
             </a:r>
             <a:r>
-              <a:rPr sz="1200">
+              <a:rPr sz="1600" dirty="0">
                 <a:solidFill>
                   <a:srgbClr val="94A3B8"/>
                 </a:solidFill>
@@ -4470,6 +4547,7 @@
           <a:lstStyle/>
           <a:p>
             <a:pPr algn="ctr"/>
+            <a:endParaRPr/>
           </a:p>
         </p:txBody>
       </p:sp>
@@ -4513,6 +4591,7 @@
           <a:lstStyle/>
           <a:p>
             <a:pPr algn="ctr"/>
+            <a:endParaRPr/>
           </a:p>
         </p:txBody>
       </p:sp>
@@ -4525,7 +4604,7 @@
         <p:spPr>
           <a:xfrm>
             <a:off x="3639312" y="1783080"/>
-            <a:ext cx="2176272" cy="4297680"/>
+            <a:ext cx="2176272" cy="3898503"/>
           </a:xfrm>
           <a:prstGeom prst="rect">
             <a:avLst/>
@@ -4550,6 +4629,7 @@
               </a:defRPr>
             </a:pPr>
             <a:r>
+              <a:rPr sz="1600" dirty="0"/>
               <a:t>STEP 2: MULTI-SCALE</a:t>
             </a:r>
           </a:p>
@@ -4560,7 +4640,7 @@
               </a:spcAft>
             </a:pPr>
             <a:r>
-              <a:rPr b="1" sz="1200">
+              <a:rPr sz="1600" b="1" dirty="0">
                 <a:solidFill>
                   <a:srgbClr val="F8FAFC"/>
                 </a:solidFill>
@@ -4568,7 +4648,7 @@
               <a:t>• Pyramidal Search: </a:t>
             </a:r>
             <a:r>
-              <a:rPr sz="1200">
+              <a:rPr sz="1600" dirty="0">
                 <a:solidFill>
                   <a:srgbClr val="94A3B8"/>
                 </a:solidFill>
@@ -4583,7 +4663,7 @@
               </a:spcAft>
             </a:pPr>
             <a:r>
-              <a:rPr b="1" sz="1200">
+              <a:rPr sz="1600" b="1" dirty="0">
                 <a:solidFill>
                   <a:srgbClr val="F8FAFC"/>
                 </a:solidFill>
@@ -4591,7 +4671,7 @@
               <a:t>• Bicubic Scaling: </a:t>
             </a:r>
             <a:r>
-              <a:rPr sz="1200">
+              <a:rPr sz="1600" dirty="0">
                 <a:solidFill>
                   <a:srgbClr val="94A3B8"/>
                 </a:solidFill>
@@ -4606,7 +4686,7 @@
               </a:spcAft>
             </a:pPr>
             <a:r>
-              <a:rPr b="1" sz="1200">
+              <a:rPr sz="1600" b="1" dirty="0">
                 <a:solidFill>
                   <a:srgbClr val="F8FAFC"/>
                 </a:solidFill>
@@ -4614,7 +4694,7 @@
               <a:t>• NCC Map: </a:t>
             </a:r>
             <a:r>
-              <a:rPr sz="1200">
+              <a:rPr sz="1600" dirty="0">
                 <a:solidFill>
                   <a:srgbClr val="94A3B8"/>
                 </a:solidFill>
@@ -4629,7 +4709,7 @@
               </a:spcAft>
             </a:pPr>
             <a:r>
-              <a:rPr b="1" sz="1200">
+              <a:rPr sz="1600" b="1" dirty="0">
                 <a:solidFill>
                   <a:srgbClr val="F8FAFC"/>
                 </a:solidFill>
@@ -4637,7 +4717,7 @@
               <a:t>• Response Tensor: </a:t>
             </a:r>
             <a:r>
-              <a:rPr sz="1200">
+              <a:rPr sz="1600" dirty="0">
                 <a:solidFill>
                   <a:srgbClr val="94A3B8"/>
                 </a:solidFill>
@@ -4689,6 +4769,7 @@
           <a:lstStyle/>
           <a:p>
             <a:pPr algn="ctr"/>
+            <a:endParaRPr/>
           </a:p>
         </p:txBody>
       </p:sp>
@@ -4732,6 +4813,7 @@
           <a:lstStyle/>
           <a:p>
             <a:pPr algn="ctr"/>
+            <a:endParaRPr/>
           </a:p>
         </p:txBody>
       </p:sp>
@@ -4744,7 +4826,7 @@
         <p:spPr>
           <a:xfrm>
             <a:off x="6364224" y="1783080"/>
-            <a:ext cx="2176272" cy="4297680"/>
+            <a:ext cx="2176272" cy="3652282"/>
           </a:xfrm>
           <a:prstGeom prst="rect">
             <a:avLst/>
@@ -4769,6 +4851,7 @@
               </a:defRPr>
             </a:pPr>
             <a:r>
+              <a:rPr sz="1600" dirty="0"/>
               <a:t>STEP 3: NMS &amp; TIE-BREAK</a:t>
             </a:r>
           </a:p>
@@ -4779,7 +4862,7 @@
               </a:spcAft>
             </a:pPr>
             <a:r>
-              <a:rPr b="1" sz="1200">
+              <a:rPr sz="1600" b="1" dirty="0">
                 <a:solidFill>
                   <a:srgbClr val="F8FAFC"/>
                 </a:solidFill>
@@ -4787,7 +4870,7 @@
               <a:t>• NMS Filtering: </a:t>
             </a:r>
             <a:r>
-              <a:rPr sz="1200">
+              <a:rPr sz="1600" dirty="0">
                 <a:solidFill>
                   <a:srgbClr val="94A3B8"/>
                 </a:solidFill>
@@ -4802,7 +4885,7 @@
               </a:spcAft>
             </a:pPr>
             <a:r>
-              <a:rPr b="1" sz="1200">
+              <a:rPr sz="1600" b="1" dirty="0">
                 <a:solidFill>
                   <a:srgbClr val="F8FAFC"/>
                 </a:solidFill>
@@ -4810,7 +4893,7 @@
               <a:t>• Periodicity Check: </a:t>
             </a:r>
             <a:r>
-              <a:rPr sz="1200">
+              <a:rPr sz="1600" dirty="0">
                 <a:solidFill>
                   <a:srgbClr val="94A3B8"/>
                 </a:solidFill>
@@ -4825,7 +4908,7 @@
               </a:spcAft>
             </a:pPr>
             <a:r>
-              <a:rPr b="1" sz="1200">
+              <a:rPr sz="1600" b="1" dirty="0">
                 <a:solidFill>
                   <a:srgbClr val="F8FAFC"/>
                 </a:solidFill>
@@ -4833,7 +4916,7 @@
               <a:t>• Stage Prior: </a:t>
             </a:r>
             <a:r>
-              <a:rPr sz="1200">
+              <a:rPr sz="1600" dirty="0">
                 <a:solidFill>
                   <a:srgbClr val="94A3B8"/>
                 </a:solidFill>
@@ -4848,7 +4931,7 @@
               </a:spcAft>
             </a:pPr>
             <a:r>
-              <a:rPr b="1" sz="1200">
+              <a:rPr sz="1600" b="1" dirty="0">
                 <a:solidFill>
                   <a:srgbClr val="F8FAFC"/>
                 </a:solidFill>
@@ -4856,7 +4939,7 @@
               <a:t>• High-Res Rescore: </a:t>
             </a:r>
             <a:r>
-              <a:rPr sz="1200">
+              <a:rPr sz="1600" dirty="0">
                 <a:solidFill>
                   <a:srgbClr val="94A3B8"/>
                 </a:solidFill>
@@ -4908,6 +4991,7 @@
           <a:lstStyle/>
           <a:p>
             <a:pPr algn="ctr"/>
+            <a:endParaRPr/>
           </a:p>
         </p:txBody>
       </p:sp>
@@ -4951,6 +5035,7 @@
           <a:lstStyle/>
           <a:p>
             <a:pPr algn="ctr"/>
+            <a:endParaRPr/>
           </a:p>
         </p:txBody>
       </p:sp>
@@ -4963,7 +5048,7 @@
         <p:spPr>
           <a:xfrm>
             <a:off x="9089136" y="1783080"/>
-            <a:ext cx="2176272" cy="4297680"/>
+            <a:ext cx="2176272" cy="3898503"/>
           </a:xfrm>
           <a:prstGeom prst="rect">
             <a:avLst/>
@@ -4988,6 +5073,7 @@
               </a:defRPr>
             </a:pPr>
             <a:r>
+              <a:rPr sz="1600" dirty="0"/>
               <a:t>STEP 4: SUB-PIXEL &amp; AI</a:t>
             </a:r>
           </a:p>
@@ -4998,7 +5084,7 @@
               </a:spcAft>
             </a:pPr>
             <a:r>
-              <a:rPr b="1" sz="1200">
+              <a:rPr sz="1600" b="1" dirty="0">
                 <a:solidFill>
                   <a:srgbClr val="F8FAFC"/>
                 </a:solidFill>
@@ -5006,7 +5092,7 @@
               <a:t>• 2D Parabola Fit: </a:t>
             </a:r>
             <a:r>
-              <a:rPr sz="1200">
+              <a:rPr sz="1600" dirty="0">
                 <a:solidFill>
                   <a:srgbClr val="94A3B8"/>
                 </a:solidFill>
@@ -5021,7 +5107,7 @@
               </a:spcAft>
             </a:pPr>
             <a:r>
-              <a:rPr b="1" sz="1200">
+              <a:rPr sz="1600" b="1" dirty="0">
                 <a:solidFill>
                   <a:srgbClr val="F8FAFC"/>
                 </a:solidFill>
@@ -5029,12 +5115,28 @@
               <a:t>• Fractional Offset: </a:t>
             </a:r>
             <a:r>
-              <a:rPr sz="1200">
-                <a:solidFill>
-                  <a:srgbClr val="94A3B8"/>
-                </a:solidFill>
-              </a:rPr>
-              <a:t>Returns dx, dy sub-pixel shifts</a:t>
+              <a:rPr sz="1600" dirty="0">
+                <a:solidFill>
+                  <a:srgbClr val="94A3B8"/>
+                </a:solidFill>
+              </a:rPr>
+              <a:t>Returns dx, </a:t>
+            </a:r>
+            <a:r>
+              <a:rPr sz="1600" dirty="0" err="1">
+                <a:solidFill>
+                  <a:srgbClr val="94A3B8"/>
+                </a:solidFill>
+              </a:rPr>
+              <a:t>dy</a:t>
+            </a:r>
+            <a:r>
+              <a:rPr sz="1600" dirty="0">
+                <a:solidFill>
+                  <a:srgbClr val="94A3B8"/>
+                </a:solidFill>
+              </a:rPr>
+              <a:t> sub-pixel shifts</a:t>
             </a:r>
           </a:p>
           <a:p>
@@ -5044,7 +5146,7 @@
               </a:spcAft>
             </a:pPr>
             <a:r>
-              <a:rPr b="1" sz="1200">
+              <a:rPr sz="1600" b="1" dirty="0">
                 <a:solidFill>
                   <a:srgbClr val="F8FAFC"/>
                 </a:solidFill>
@@ -5052,13 +5154,42 @@
               <a:t>• AI Fallback: </a:t>
             </a:r>
             <a:r>
-              <a:rPr sz="1200">
-                <a:solidFill>
-                  <a:srgbClr val="94A3B8"/>
-                </a:solidFill>
-              </a:rPr>
-              <a:t>ORB Keypoints + RANSAC Homography</a:t>
-            </a:r>
+              <a:rPr sz="1600" dirty="0">
+                <a:solidFill>
+                  <a:srgbClr val="94A3B8"/>
+                </a:solidFill>
+              </a:rPr>
+              <a:t>ORB </a:t>
+            </a:r>
+            <a:r>
+              <a:rPr sz="1600" dirty="0" err="1">
+                <a:solidFill>
+                  <a:srgbClr val="94A3B8"/>
+                </a:solidFill>
+              </a:rPr>
+              <a:t>Keypoints</a:t>
+            </a:r>
+            <a:r>
+              <a:rPr sz="1600" dirty="0">
+                <a:solidFill>
+                  <a:srgbClr val="94A3B8"/>
+                </a:solidFill>
+              </a:rPr>
+              <a:t> + RANSAC </a:t>
+            </a:r>
+            <a:r>
+              <a:rPr sz="1600" dirty="0" err="1">
+                <a:solidFill>
+                  <a:srgbClr val="94A3B8"/>
+                </a:solidFill>
+              </a:rPr>
+              <a:t>Homography</a:t>
+            </a:r>
+            <a:endParaRPr sz="1600" dirty="0">
+              <a:solidFill>
+                <a:srgbClr val="94A3B8"/>
+              </a:solidFill>
+            </a:endParaRPr>
           </a:p>
           <a:p>
             <a:pPr>
@@ -5067,7 +5198,7 @@
               </a:spcAft>
             </a:pPr>
             <a:r>
-              <a:rPr b="1" sz="1200">
+              <a:rPr sz="1600" b="1" dirty="0">
                 <a:solidFill>
                   <a:srgbClr val="F8FAFC"/>
                 </a:solidFill>
@@ -5075,7 +5206,7 @@
               <a:t>• Final Output: </a:t>
             </a:r>
             <a:r>
-              <a:rPr sz="1200">
+              <a:rPr sz="1600" dirty="0">
                 <a:solidFill>
                   <a:srgbClr val="94A3B8"/>
                 </a:solidFill>
@@ -5094,7 +5225,7 @@
 </file>
 
 <file path=ppt/slides/slide4.xml><?xml version="1.0" encoding="utf-8"?>
-<p:sld xmlns:a="http://schemas.openxmlformats.org/drawingml/2006/main" xmlns:p="http://schemas.openxmlformats.org/presentationml/2006/main" xmlns:r="http://schemas.openxmlformats.org/officeDocument/2006/relationships">
+<p:sld xmlns:a="http://schemas.openxmlformats.org/drawingml/2006/main" xmlns:r="http://schemas.openxmlformats.org/officeDocument/2006/relationships" xmlns:p="http://schemas.openxmlformats.org/presentationml/2006/main">
   <p:cSld>
     <p:spTree>
       <p:nvGrpSpPr>
@@ -5102,7 +5233,14 @@
         <p:cNvGrpSpPr/>
         <p:nvPr/>
       </p:nvGrpSpPr>
-      <p:grpSpPr/>
+      <p:grpSpPr>
+        <a:xfrm>
+          <a:off x="0" y="0"/>
+          <a:ext cx="0" cy="0"/>
+          <a:chOff x="0" y="0"/>
+          <a:chExt cx="0" cy="0"/>
+        </a:xfrm>
+      </p:grpSpPr>
       <p:sp>
         <p:nvSpPr>
           <p:cNvPr id="2" name="Rectangle 1"/>
@@ -5143,6 +5281,7 @@
           <a:lstStyle/>
           <a:p>
             <a:pPr algn="ctr"/>
+            <a:endParaRPr/>
           </a:p>
         </p:txBody>
       </p:sp>
@@ -5154,8 +5293,8 @@
         </p:nvSpPr>
         <p:spPr>
           <a:xfrm>
-            <a:off x="731520" y="365760"/>
-            <a:ext cx="9144000" cy="365760"/>
+            <a:off x="649224" y="471109"/>
+            <a:ext cx="9144000" cy="276999"/>
           </a:xfrm>
           <a:prstGeom prst="rect">
             <a:avLst/>
@@ -5177,6 +5316,7 @@
               </a:defRPr>
             </a:pPr>
             <a:r>
+              <a:rPr sz="1200" dirty="0"/>
               <a:t>DRIFT-SENSE / SEMICONDUCTOR ALGORITHMIC TOOLING</a:t>
             </a:r>
           </a:p>
@@ -5190,8 +5330,8 @@
         </p:nvSpPr>
         <p:spPr>
           <a:xfrm>
-            <a:off x="731520" y="640080"/>
-            <a:ext cx="10515600" cy="731520"/>
+            <a:off x="649224" y="791149"/>
+            <a:ext cx="10515600" cy="492443"/>
           </a:xfrm>
           <a:prstGeom prst="rect">
             <a:avLst/>
@@ -5213,7 +5353,12 @@
               </a:defRPr>
             </a:pPr>
             <a:r>
-              <a:t>Member B Algorithmic Core: Preprocessing &amp; Pyramids</a:t>
+              <a:rPr lang="en-US" dirty="0"/>
+              <a:t>Krish Deshpande :</a:t>
+            </a:r>
+            <a:r>
+              <a:rPr dirty="0"/>
+              <a:t> Algorithmic Core: Preprocessing &amp; Pyramids</a:t>
             </a:r>
           </a:p>
         </p:txBody>
@@ -5260,6 +5405,7 @@
           <a:lstStyle/>
           <a:p>
             <a:pPr algn="ctr"/>
+            <a:endParaRPr/>
           </a:p>
         </p:txBody>
       </p:sp>
@@ -5303,6 +5449,7 @@
           <a:lstStyle/>
           <a:p>
             <a:pPr algn="ctr"/>
+            <a:endParaRPr/>
           </a:p>
         </p:txBody>
       </p:sp>
@@ -5315,7 +5462,7 @@
         <p:spPr>
           <a:xfrm>
             <a:off x="914400" y="1783080"/>
-            <a:ext cx="4809744" cy="4297680"/>
+            <a:ext cx="4809744" cy="3406061"/>
           </a:xfrm>
           <a:prstGeom prst="rect">
             <a:avLst/>
@@ -5340,7 +5487,16 @@
               </a:defRPr>
             </a:pPr>
             <a:r>
-              <a:t>Adaptive Intensity Preprocessing (src/preprocess.py)</a:t>
+              <a:rPr sz="1600" dirty="0"/>
+              <a:t>Adaptive Intensity Preprocessing (</a:t>
+            </a:r>
+            <a:r>
+              <a:rPr sz="1600" dirty="0" err="1"/>
+              <a:t>src</a:t>
+            </a:r>
+            <a:r>
+              <a:rPr sz="1600" dirty="0"/>
+              <a:t>/preprocess.py)</a:t>
             </a:r>
           </a:p>
           <a:p>
@@ -5350,7 +5506,7 @@
               </a:spcAft>
             </a:pPr>
             <a:r>
-              <a:rPr b="1" sz="1200">
+              <a:rPr sz="1600" b="1" dirty="0">
                 <a:solidFill>
                   <a:srgbClr val="F8FAFC"/>
                 </a:solidFill>
@@ -5358,7 +5514,7 @@
               <a:t>• CLAHE Contrast Equalization: </a:t>
             </a:r>
             <a:r>
-              <a:rPr sz="1200">
+              <a:rPr sz="1600" dirty="0">
                 <a:solidFill>
                   <a:srgbClr val="94A3B8"/>
                 </a:solidFill>
@@ -5373,7 +5529,7 @@
               </a:spcAft>
             </a:pPr>
             <a:r>
-              <a:rPr b="1" sz="1200">
+              <a:rPr sz="1600" b="1" dirty="0">
                 <a:solidFill>
                   <a:srgbClr val="F8FAFC"/>
                 </a:solidFill>
@@ -5381,7 +5537,7 @@
               <a:t>• Gaussian Denoising (3x3): </a:t>
             </a:r>
             <a:r>
-              <a:rPr sz="1200">
+              <a:rPr sz="1600" dirty="0">
                 <a:solidFill>
                   <a:srgbClr val="94A3B8"/>
                 </a:solidFill>
@@ -5396,7 +5552,7 @@
               </a:spcAft>
             </a:pPr>
             <a:r>
-              <a:rPr b="1" sz="1200">
+              <a:rPr sz="1600" b="1" dirty="0">
                 <a:solidFill>
                   <a:srgbClr val="F8FAFC"/>
                 </a:solidFill>
@@ -5404,7 +5560,7 @@
               <a:t>• Sobel Gradient Magnitude: </a:t>
             </a:r>
             <a:r>
-              <a:rPr sz="1200">
+              <a:rPr sz="1600" dirty="0">
                 <a:solidFill>
                   <a:srgbClr val="94A3B8"/>
                 </a:solidFill>
@@ -5419,7 +5575,7 @@
               </a:spcAft>
             </a:pPr>
             <a:r>
-              <a:rPr b="1" sz="1200">
+              <a:rPr sz="1600" b="1" dirty="0">
                 <a:solidFill>
                   <a:srgbClr val="F8FAFC"/>
                 </a:solidFill>
@@ -5427,7 +5583,7 @@
               <a:t>• Z-Score Calibration: </a:t>
             </a:r>
             <a:r>
-              <a:rPr sz="1200">
+              <a:rPr sz="1600" dirty="0">
                 <a:solidFill>
                   <a:srgbClr val="94A3B8"/>
                 </a:solidFill>
@@ -5479,6 +5635,7 @@
           <a:lstStyle/>
           <a:p>
             <a:pPr algn="ctr"/>
+            <a:endParaRPr/>
           </a:p>
         </p:txBody>
       </p:sp>
@@ -5522,6 +5679,7 @@
           <a:lstStyle/>
           <a:p>
             <a:pPr algn="ctr"/>
+            <a:endParaRPr/>
           </a:p>
         </p:txBody>
       </p:sp>
@@ -5534,7 +5692,7 @@
         <p:spPr>
           <a:xfrm>
             <a:off x="6455664" y="1783080"/>
-            <a:ext cx="4809744" cy="4297680"/>
+            <a:ext cx="4809744" cy="3159839"/>
           </a:xfrm>
           <a:prstGeom prst="rect">
             <a:avLst/>
@@ -5559,7 +5717,16 @@
               </a:defRPr>
             </a:pPr>
             <a:r>
-              <a:t>Pyramidal Multi-Scale Search Space (src/matcher.py)</a:t>
+              <a:rPr sz="1600" dirty="0"/>
+              <a:t>Pyramidal Multi-Scale Search Space (</a:t>
+            </a:r>
+            <a:r>
+              <a:rPr sz="1600" dirty="0" err="1"/>
+              <a:t>src</a:t>
+            </a:r>
+            <a:r>
+              <a:rPr sz="1600" dirty="0"/>
+              <a:t>/matcher.py)</a:t>
             </a:r>
           </a:p>
           <a:p>
@@ -5569,7 +5736,7 @@
               </a:spcAft>
             </a:pPr>
             <a:r>
-              <a:rPr b="1" sz="1200">
+              <a:rPr sz="1600" b="1" dirty="0">
                 <a:solidFill>
                   <a:srgbClr val="F8FAFC"/>
                 </a:solidFill>
@@ -5577,12 +5744,60 @@
               <a:t>• Scale Invariance: </a:t>
             </a:r>
             <a:r>
-              <a:rPr sz="1200">
-                <a:solidFill>
-                  <a:srgbClr val="94A3B8"/>
-                </a:solidFill>
-              </a:rPr>
-              <a:t>Evaluates template scale hypotheses across s in {s_base * 0.95, s_base, s_base * 1.05}.</a:t>
+              <a:rPr sz="1600" dirty="0">
+                <a:solidFill>
+                  <a:srgbClr val="94A3B8"/>
+                </a:solidFill>
+              </a:rPr>
+              <a:t>Evaluates template scale hypotheses across s in {</a:t>
+            </a:r>
+            <a:r>
+              <a:rPr sz="1600" dirty="0" err="1">
+                <a:solidFill>
+                  <a:srgbClr val="94A3B8"/>
+                </a:solidFill>
+              </a:rPr>
+              <a:t>s_base</a:t>
+            </a:r>
+            <a:r>
+              <a:rPr sz="1600" dirty="0">
+                <a:solidFill>
+                  <a:srgbClr val="94A3B8"/>
+                </a:solidFill>
+              </a:rPr>
+              <a:t> * 0.95, </a:t>
+            </a:r>
+            <a:r>
+              <a:rPr sz="1600" dirty="0" err="1">
+                <a:solidFill>
+                  <a:srgbClr val="94A3B8"/>
+                </a:solidFill>
+              </a:rPr>
+              <a:t>s_base</a:t>
+            </a:r>
+            <a:r>
+              <a:rPr sz="1600" dirty="0">
+                <a:solidFill>
+                  <a:srgbClr val="94A3B8"/>
+                </a:solidFill>
+              </a:rPr>
+              <a:t>, </a:t>
+            </a:r>
+            <a:r>
+              <a:rPr sz="1600" dirty="0" err="1">
+                <a:solidFill>
+                  <a:srgbClr val="94A3B8"/>
+                </a:solidFill>
+              </a:rPr>
+              <a:t>s_base</a:t>
+            </a:r>
+            <a:r>
+              <a:rPr sz="1600" dirty="0">
+                <a:solidFill>
+                  <a:srgbClr val="94A3B8"/>
+                </a:solidFill>
+              </a:rPr>
+              <a:t> * 1.05}.</a:t>
             </a:r>
           </a:p>
           <a:p>
@@ -5592,7 +5807,7 @@
               </a:spcAft>
             </a:pPr>
             <a:r>
-              <a:rPr b="1" sz="1200">
+              <a:rPr sz="1600" b="1" dirty="0">
                 <a:solidFill>
                   <a:srgbClr val="F8FAFC"/>
                 </a:solidFill>
@@ -5600,7 +5815,7 @@
               <a:t>• Bicubic &amp; Area Resampling: </a:t>
             </a:r>
             <a:r>
-              <a:rPr sz="1200">
+              <a:rPr sz="1600" dirty="0">
                 <a:solidFill>
                   <a:srgbClr val="94A3B8"/>
                 </a:solidFill>
@@ -5615,7 +5830,7 @@
               </a:spcAft>
             </a:pPr>
             <a:r>
-              <a:rPr b="1" sz="1200">
+              <a:rPr sz="1600" b="1" dirty="0">
                 <a:solidFill>
                   <a:srgbClr val="F8FAFC"/>
                 </a:solidFill>
@@ -5623,7 +5838,7 @@
               <a:t>• Normalized Cross-Correlation (NCC): </a:t>
             </a:r>
             <a:r>
-              <a:rPr sz="1200">
+              <a:rPr sz="1600" dirty="0">
                 <a:solidFill>
                   <a:srgbClr val="94A3B8"/>
                 </a:solidFill>
@@ -5638,7 +5853,7 @@
               </a:spcAft>
             </a:pPr>
             <a:r>
-              <a:rPr b="1" sz="1200">
+              <a:rPr sz="1600" b="1" dirty="0">
                 <a:solidFill>
                   <a:srgbClr val="F8FAFC"/>
                 </a:solidFill>
@@ -5646,7 +5861,7 @@
               <a:t>• 0ms Training Latency: </a:t>
             </a:r>
             <a:r>
-              <a:rPr sz="1200">
+              <a:rPr sz="1600" dirty="0">
                 <a:solidFill>
                   <a:srgbClr val="94A3B8"/>
                 </a:solidFill>
@@ -5665,7 +5880,7 @@
 </file>
 
 <file path=ppt/slides/slide5.xml><?xml version="1.0" encoding="utf-8"?>
-<p:sld xmlns:a="http://schemas.openxmlformats.org/drawingml/2006/main" xmlns:p="http://schemas.openxmlformats.org/presentationml/2006/main" xmlns:r="http://schemas.openxmlformats.org/officeDocument/2006/relationships">
+<p:sld xmlns:a="http://schemas.openxmlformats.org/drawingml/2006/main" xmlns:r="http://schemas.openxmlformats.org/officeDocument/2006/relationships" xmlns:p="http://schemas.openxmlformats.org/presentationml/2006/main">
   <p:cSld>
     <p:spTree>
       <p:nvGrpSpPr>
@@ -5673,7 +5888,14 @@
         <p:cNvGrpSpPr/>
         <p:nvPr/>
       </p:nvGrpSpPr>
-      <p:grpSpPr/>
+      <p:grpSpPr>
+        <a:xfrm>
+          <a:off x="0" y="0"/>
+          <a:ext cx="0" cy="0"/>
+          <a:chOff x="0" y="0"/>
+          <a:chExt cx="0" cy="0"/>
+        </a:xfrm>
+      </p:grpSpPr>
       <p:sp>
         <p:nvSpPr>
           <p:cNvPr id="2" name="Rectangle 1"/>
@@ -5714,6 +5936,7 @@
           <a:lstStyle/>
           <a:p>
             <a:pPr algn="ctr"/>
+            <a:endParaRPr/>
           </a:p>
         </p:txBody>
       </p:sp>
@@ -5725,8 +5948,8 @@
         </p:nvSpPr>
         <p:spPr>
           <a:xfrm>
-            <a:off x="731520" y="365760"/>
-            <a:ext cx="9144000" cy="365760"/>
+            <a:off x="749808" y="561252"/>
+            <a:ext cx="9144000" cy="276999"/>
           </a:xfrm>
           <a:prstGeom prst="rect">
             <a:avLst/>
@@ -5748,6 +5971,7 @@
               </a:defRPr>
             </a:pPr>
             <a:r>
+              <a:rPr sz="1200" dirty="0"/>
               <a:t>DRIFT-SENSE / SEMICONDUCTOR ALGORITHMIC TOOLING</a:t>
             </a:r>
           </a:p>
@@ -5761,7 +5985,7 @@
         </p:nvSpPr>
         <p:spPr>
           <a:xfrm>
-            <a:off x="731520" y="640080"/>
+            <a:off x="731520" y="914400"/>
             <a:ext cx="10515600" cy="731520"/>
           </a:xfrm>
           <a:prstGeom prst="rect">
@@ -5784,6 +6008,7 @@
               </a:defRPr>
             </a:pPr>
             <a:r>
+              <a:rPr dirty="0"/>
               <a:t>Periodicity Tie-Breaking &amp; Sub-Pixel Parabolic Fit</a:t>
             </a:r>
           </a:p>
@@ -5831,6 +6056,7 @@
           <a:lstStyle/>
           <a:p>
             <a:pPr algn="ctr"/>
+            <a:endParaRPr/>
           </a:p>
         </p:txBody>
       </p:sp>
@@ -5874,6 +6100,7 @@
           <a:lstStyle/>
           <a:p>
             <a:pPr algn="ctr"/>
+            <a:endParaRPr/>
           </a:p>
         </p:txBody>
       </p:sp>
@@ -5886,7 +6113,7 @@
         <p:spPr>
           <a:xfrm>
             <a:off x="914400" y="1783080"/>
-            <a:ext cx="4809744" cy="4297680"/>
+            <a:ext cx="4809744" cy="3159839"/>
           </a:xfrm>
           <a:prstGeom prst="rect">
             <a:avLst/>
@@ -5911,7 +6138,16 @@
               </a:defRPr>
             </a:pPr>
             <a:r>
-              <a:t>Periodicity &amp; Stage Prior Tie-Breaking (src/peaks.py)</a:t>
+              <a:rPr sz="1600" dirty="0"/>
+              <a:t>Periodicity &amp; Stage Prior Tie-Breaking (</a:t>
+            </a:r>
+            <a:r>
+              <a:rPr sz="1600" dirty="0" err="1"/>
+              <a:t>src</a:t>
+            </a:r>
+            <a:r>
+              <a:rPr sz="1600" dirty="0"/>
+              <a:t>/peaks.py)</a:t>
             </a:r>
           </a:p>
           <a:p>
@@ -5921,7 +6157,7 @@
               </a:spcAft>
             </a:pPr>
             <a:r>
-              <a:rPr b="1" sz="1200">
+              <a:rPr sz="1600" b="1" dirty="0">
                 <a:solidFill>
                   <a:srgbClr val="F8FAFC"/>
                 </a:solidFill>
@@ -5929,7 +6165,7 @@
               <a:t>• Non-Maximum Suppression (NMS): </a:t>
             </a:r>
             <a:r>
-              <a:rPr sz="1200">
+              <a:rPr sz="1600" dirty="0">
                 <a:solidFill>
                   <a:srgbClr val="94A3B8"/>
                 </a:solidFill>
@@ -5944,7 +6180,7 @@
               </a:spcAft>
             </a:pPr>
             <a:r>
-              <a:rPr b="1" sz="1200">
+              <a:rPr sz="1600" b="1" dirty="0">
                 <a:solidFill>
                   <a:srgbClr val="F8FAFC"/>
                 </a:solidFill>
@@ -5952,7 +6188,7 @@
               <a:t>• Grid Ambiguity Detection: </a:t>
             </a:r>
             <a:r>
-              <a:rPr sz="1200">
+              <a:rPr sz="1600" dirty="0">
                 <a:solidFill>
                   <a:srgbClr val="94A3B8"/>
                 </a:solidFill>
@@ -5967,7 +6203,7 @@
               </a:spcAft>
             </a:pPr>
             <a:r>
-              <a:rPr b="1" sz="1200">
+              <a:rPr sz="1600" b="1" dirty="0">
                 <a:solidFill>
                   <a:srgbClr val="F8FAFC"/>
                 </a:solidFill>
@@ -5975,7 +6211,7 @@
               <a:t>• Physical Stage Prior: </a:t>
             </a:r>
             <a:r>
-              <a:rPr sz="1200">
+              <a:rPr sz="1600" dirty="0">
                 <a:solidFill>
                   <a:srgbClr val="94A3B8"/>
                 </a:solidFill>
@@ -5990,7 +6226,7 @@
               </a:spcAft>
             </a:pPr>
             <a:r>
-              <a:rPr b="1" sz="1200">
+              <a:rPr sz="1600" b="1" dirty="0">
                 <a:solidFill>
                   <a:srgbClr val="F8FAFC"/>
                 </a:solidFill>
@@ -5998,12 +6234,44 @@
               <a:t>• Composite Fitness Score: </a:t>
             </a:r>
             <a:r>
-              <a:rPr sz="1200">
-                <a:solidFill>
-                  <a:srgbClr val="94A3B8"/>
-                </a:solidFill>
-              </a:rPr>
-              <a:t>Fitness = 0.8 * NormScore + 0.2 * (1 - NormDistPenalty).</a:t>
+              <a:rPr sz="1600" dirty="0">
+                <a:solidFill>
+                  <a:srgbClr val="94A3B8"/>
+                </a:solidFill>
+              </a:rPr>
+              <a:t>Fitness = 0.8 * </a:t>
+            </a:r>
+            <a:r>
+              <a:rPr sz="1600" dirty="0" err="1">
+                <a:solidFill>
+                  <a:srgbClr val="94A3B8"/>
+                </a:solidFill>
+              </a:rPr>
+              <a:t>NormScore</a:t>
+            </a:r>
+            <a:r>
+              <a:rPr sz="1600" dirty="0">
+                <a:solidFill>
+                  <a:srgbClr val="94A3B8"/>
+                </a:solidFill>
+              </a:rPr>
+              <a:t> + 0.2 * (1 - </a:t>
+            </a:r>
+            <a:r>
+              <a:rPr sz="1600" dirty="0" err="1">
+                <a:solidFill>
+                  <a:srgbClr val="94A3B8"/>
+                </a:solidFill>
+              </a:rPr>
+              <a:t>NormDistPenalty</a:t>
+            </a:r>
+            <a:r>
+              <a:rPr sz="1600" dirty="0">
+                <a:solidFill>
+                  <a:srgbClr val="94A3B8"/>
+                </a:solidFill>
+              </a:rPr>
+              <a:t>).</a:t>
             </a:r>
           </a:p>
         </p:txBody>
@@ -6050,6 +6318,7 @@
           <a:lstStyle/>
           <a:p>
             <a:pPr algn="ctr"/>
+            <a:endParaRPr/>
           </a:p>
         </p:txBody>
       </p:sp>
@@ -6093,6 +6362,7 @@
           <a:lstStyle/>
           <a:p>
             <a:pPr algn="ctr"/>
+            <a:endParaRPr/>
           </a:p>
         </p:txBody>
       </p:sp>
@@ -6105,7 +6375,7 @@
         <p:spPr>
           <a:xfrm>
             <a:off x="6455664" y="1783080"/>
-            <a:ext cx="4809744" cy="4297680"/>
+            <a:ext cx="4809744" cy="2913618"/>
           </a:xfrm>
           <a:prstGeom prst="rect">
             <a:avLst/>
@@ -6130,7 +6400,16 @@
               </a:defRPr>
             </a:pPr>
             <a:r>
-              <a:t>Sub-Pixel Quadratic Surface Fit (src/peaks.py)</a:t>
+              <a:rPr sz="1600" dirty="0"/>
+              <a:t>Sub-Pixel Quadratic Surface Fit (</a:t>
+            </a:r>
+            <a:r>
+              <a:rPr sz="1600" dirty="0" err="1"/>
+              <a:t>src</a:t>
+            </a:r>
+            <a:r>
+              <a:rPr sz="1600" dirty="0"/>
+              <a:t>/peaks.py)</a:t>
             </a:r>
           </a:p>
           <a:p>
@@ -6140,7 +6419,7 @@
               </a:spcAft>
             </a:pPr>
             <a:r>
-              <a:rPr b="1" sz="1200">
+              <a:rPr sz="1600" b="1" dirty="0">
                 <a:solidFill>
                   <a:srgbClr val="F8FAFC"/>
                 </a:solidFill>
@@ -6148,12 +6427,28 @@
               <a:t>• Discretization Limit: </a:t>
             </a:r>
             <a:r>
-              <a:rPr sz="1200">
-                <a:solidFill>
-                  <a:srgbClr val="94A3B8"/>
-                </a:solidFill>
-              </a:rPr>
-              <a:t>Camera sensor pixels discritize position into 1px steps (~500nm).</a:t>
+              <a:rPr sz="1600" dirty="0">
+                <a:solidFill>
+                  <a:srgbClr val="94A3B8"/>
+                </a:solidFill>
+              </a:rPr>
+              <a:t>Camera sensor pixels </a:t>
+            </a:r>
+            <a:r>
+              <a:rPr sz="1600" dirty="0" err="1">
+                <a:solidFill>
+                  <a:srgbClr val="94A3B8"/>
+                </a:solidFill>
+              </a:rPr>
+              <a:t>discritize</a:t>
+            </a:r>
+            <a:r>
+              <a:rPr sz="1600" dirty="0">
+                <a:solidFill>
+                  <a:srgbClr val="94A3B8"/>
+                </a:solidFill>
+              </a:rPr>
+              <a:t> position into 1px steps (~500nm).</a:t>
             </a:r>
           </a:p>
           <a:p>
@@ -6163,7 +6458,7 @@
               </a:spcAft>
             </a:pPr>
             <a:r>
-              <a:rPr b="1" sz="1200">
+              <a:rPr sz="1600" b="1" dirty="0">
                 <a:solidFill>
                   <a:srgbClr val="F8FAFC"/>
                 </a:solidFill>
@@ -6171,7 +6466,7 @@
               <a:t>• 2D Parabolic Interpolation: </a:t>
             </a:r>
             <a:r>
-              <a:rPr sz="1200">
+              <a:rPr sz="1600" dirty="0">
                 <a:solidFill>
                   <a:srgbClr val="94A3B8"/>
                 </a:solidFill>
@@ -6186,7 +6481,7 @@
               </a:spcAft>
             </a:pPr>
             <a:r>
-              <a:rPr b="1" sz="1200">
+              <a:rPr sz="1600" b="1" dirty="0">
                 <a:solidFill>
                   <a:srgbClr val="F8FAFC"/>
                 </a:solidFill>
@@ -6194,7 +6489,7 @@
               <a:t>• Fractional Shift Equation: </a:t>
             </a:r>
             <a:r>
-              <a:rPr sz="1200">
+              <a:rPr sz="1600" dirty="0">
                 <a:solidFill>
                   <a:srgbClr val="94A3B8"/>
                 </a:solidFill>
@@ -6209,7 +6504,7 @@
               </a:spcAft>
             </a:pPr>
             <a:r>
-              <a:rPr b="1" sz="1200">
+              <a:rPr sz="1600" b="1" dirty="0">
                 <a:solidFill>
                   <a:srgbClr val="F8FAFC"/>
                 </a:solidFill>
@@ -6217,12 +6512,28 @@
               <a:t>• Extreme Precision: </a:t>
             </a:r>
             <a:r>
-              <a:rPr sz="1200">
-                <a:solidFill>
-                  <a:srgbClr val="94A3B8"/>
-                </a:solidFill>
-              </a:rPr>
-              <a:t>Achieves nanometer-level spatial localization (&lt; 0.03 px error).</a:t>
+              <a:rPr sz="1600" dirty="0">
+                <a:solidFill>
+                  <a:srgbClr val="94A3B8"/>
+                </a:solidFill>
+              </a:rPr>
+              <a:t>Achieves nanometer-level spatial localization (&lt; 0.03 </a:t>
+            </a:r>
+            <a:r>
+              <a:rPr sz="1600" dirty="0" err="1">
+                <a:solidFill>
+                  <a:srgbClr val="94A3B8"/>
+                </a:solidFill>
+              </a:rPr>
+              <a:t>px</a:t>
+            </a:r>
+            <a:r>
+              <a:rPr sz="1600" dirty="0">
+                <a:solidFill>
+                  <a:srgbClr val="94A3B8"/>
+                </a:solidFill>
+              </a:rPr>
+              <a:t> error).</a:t>
             </a:r>
           </a:p>
         </p:txBody>
@@ -6236,7 +6547,7 @@
 </file>
 
 <file path=ppt/slides/slide6.xml><?xml version="1.0" encoding="utf-8"?>
-<p:sld xmlns:a="http://schemas.openxmlformats.org/drawingml/2006/main" xmlns:p="http://schemas.openxmlformats.org/presentationml/2006/main" xmlns:r="http://schemas.openxmlformats.org/officeDocument/2006/relationships">
+<p:sld xmlns:a="http://schemas.openxmlformats.org/drawingml/2006/main" xmlns:r="http://schemas.openxmlformats.org/officeDocument/2006/relationships" xmlns:p="http://schemas.openxmlformats.org/presentationml/2006/main">
   <p:cSld>
     <p:spTree>
       <p:nvGrpSpPr>
@@ -6244,7 +6555,14 @@
         <p:cNvGrpSpPr/>
         <p:nvPr/>
       </p:nvGrpSpPr>
-      <p:grpSpPr/>
+      <p:grpSpPr>
+        <a:xfrm>
+          <a:off x="0" y="0"/>
+          <a:ext cx="0" cy="0"/>
+          <a:chOff x="0" y="0"/>
+          <a:chExt cx="0" cy="0"/>
+        </a:xfrm>
+      </p:grpSpPr>
       <p:sp>
         <p:nvSpPr>
           <p:cNvPr id="2" name="Rectangle 1"/>
@@ -6285,6 +6603,7 @@
           <a:lstStyle/>
           <a:p>
             <a:pPr algn="ctr"/>
+            <a:endParaRPr/>
           </a:p>
         </p:txBody>
       </p:sp>
@@ -6296,8 +6615,8 @@
         </p:nvSpPr>
         <p:spPr>
           <a:xfrm>
-            <a:off x="731520" y="365760"/>
-            <a:ext cx="9144000" cy="365760"/>
+            <a:off x="731520" y="548640"/>
+            <a:ext cx="9144000" cy="276999"/>
           </a:xfrm>
           <a:prstGeom prst="rect">
             <a:avLst/>
@@ -6319,6 +6638,7 @@
               </a:defRPr>
             </a:pPr>
             <a:r>
+              <a:rPr sz="1200" dirty="0"/>
               <a:t>DRIFT-SENSE / SEMICONDUCTOR ALGORITHMIC TOOLING</a:t>
             </a:r>
           </a:p>
@@ -6332,7 +6652,7 @@
         </p:nvSpPr>
         <p:spPr>
           <a:xfrm>
-            <a:off x="731520" y="640080"/>
+            <a:off x="731520" y="824537"/>
             <a:ext cx="10515600" cy="731520"/>
           </a:xfrm>
           <a:prstGeom prst="rect">
@@ -6355,6 +6675,7 @@
               </a:defRPr>
             </a:pPr>
             <a:r>
+              <a:rPr dirty="0"/>
               <a:t>AI Feature Matching Fallback &amp; Resilience</a:t>
             </a:r>
           </a:p>
@@ -6402,6 +6723,7 @@
           <a:lstStyle/>
           <a:p>
             <a:pPr algn="ctr"/>
+            <a:endParaRPr/>
           </a:p>
         </p:txBody>
       </p:sp>
@@ -6445,6 +6767,7 @@
           <a:lstStyle/>
           <a:p>
             <a:pPr algn="ctr"/>
+            <a:endParaRPr/>
           </a:p>
         </p:txBody>
       </p:sp>
@@ -6456,8 +6779,8 @@
         </p:nvSpPr>
         <p:spPr>
           <a:xfrm>
-            <a:off x="914400" y="1783080"/>
-            <a:ext cx="10362895" cy="4297680"/>
+            <a:off x="914400" y="1979203"/>
+            <a:ext cx="10332719" cy="2498120"/>
           </a:xfrm>
           <a:prstGeom prst="rect">
             <a:avLst/>
@@ -6482,6 +6805,7 @@
               </a:defRPr>
             </a:pPr>
             <a:r>
+              <a:rPr sz="1600" dirty="0"/>
               <a:t>Zero-Shot AI Feature Matching Engine (ORB + RANSAC)</a:t>
             </a:r>
           </a:p>
@@ -6492,7 +6816,7 @@
               </a:spcAft>
             </a:pPr>
             <a:r>
-              <a:rPr b="1" sz="1200">
+              <a:rPr sz="1600" b="1" dirty="0">
                 <a:solidFill>
                   <a:srgbClr val="F8FAFC"/>
                 </a:solidFill>
@@ -6500,7 +6824,7 @@
               <a:t>• Dynamic Trigger: </a:t>
             </a:r>
             <a:r>
-              <a:rPr sz="1200">
+              <a:rPr sz="1600" dirty="0">
                 <a:solidFill>
                   <a:srgbClr val="94A3B8"/>
                 </a:solidFill>
@@ -6515,20 +6839,52 @@
               </a:spcAft>
             </a:pPr>
             <a:r>
-              <a:rPr b="1" sz="1200">
+              <a:rPr sz="1600" b="1" dirty="0">
                 <a:solidFill>
                   <a:srgbClr val="F8FAFC"/>
                 </a:solidFill>
               </a:rPr>
-              <a:t>• ORB Keypoint Extraction: </a:t>
-            </a:r>
-            <a:r>
-              <a:rPr sz="1200">
-                <a:solidFill>
-                  <a:srgbClr val="94A3B8"/>
-                </a:solidFill>
-              </a:rPr>
-              <a:t>Detects 1,000 scale-invariant oriented FAST keypoints and binary BRIEF descriptors.</a:t>
+              <a:t>• ORB </a:t>
+            </a:r>
+            <a:r>
+              <a:rPr sz="1600" b="1" dirty="0" err="1">
+                <a:solidFill>
+                  <a:srgbClr val="F8FAFC"/>
+                </a:solidFill>
+              </a:rPr>
+              <a:t>Keypoint</a:t>
+            </a:r>
+            <a:r>
+              <a:rPr sz="1600" b="1" dirty="0">
+                <a:solidFill>
+                  <a:srgbClr val="F8FAFC"/>
+                </a:solidFill>
+              </a:rPr>
+              <a:t> Extraction: </a:t>
+            </a:r>
+            <a:r>
+              <a:rPr sz="1600" dirty="0">
+                <a:solidFill>
+                  <a:srgbClr val="94A3B8"/>
+                </a:solidFill>
+              </a:rPr>
+              <a:t>Detects 1,000 scale-invariant oriented FAST </a:t>
+            </a:r>
+            <a:r>
+              <a:rPr sz="1600" dirty="0" err="1">
+                <a:solidFill>
+                  <a:srgbClr val="94A3B8"/>
+                </a:solidFill>
+              </a:rPr>
+              <a:t>keypoints</a:t>
+            </a:r>
+            <a:r>
+              <a:rPr sz="1600" dirty="0">
+                <a:solidFill>
+                  <a:srgbClr val="94A3B8"/>
+                </a:solidFill>
+              </a:rPr>
+              <a:t> and binary BRIEF descriptors.</a:t>
             </a:r>
           </a:p>
           <a:p>
@@ -6538,7 +6894,7 @@
               </a:spcAft>
             </a:pPr>
             <a:r>
-              <a:rPr b="1" sz="1200">
+              <a:rPr sz="1600" b="1" dirty="0">
                 <a:solidFill>
                   <a:srgbClr val="F8FAFC"/>
                 </a:solidFill>
@@ -6546,12 +6902,28 @@
               <a:t>• FLANN / Brute-Force Matcher: </a:t>
             </a:r>
             <a:r>
-              <a:rPr sz="1200">
-                <a:solidFill>
-                  <a:srgbClr val="94A3B8"/>
-                </a:solidFill>
-              </a:rPr>
-              <a:t>Computes Hamming distance between reference and search keypoint descriptors.</a:t>
+              <a:rPr sz="1600" dirty="0">
+                <a:solidFill>
+                  <a:srgbClr val="94A3B8"/>
+                </a:solidFill>
+              </a:rPr>
+              <a:t>Computes Hamming distance between reference and search </a:t>
+            </a:r>
+            <a:r>
+              <a:rPr sz="1600" dirty="0" err="1">
+                <a:solidFill>
+                  <a:srgbClr val="94A3B8"/>
+                </a:solidFill>
+              </a:rPr>
+              <a:t>keypoint</a:t>
+            </a:r>
+            <a:r>
+              <a:rPr sz="1600" dirty="0">
+                <a:solidFill>
+                  <a:srgbClr val="94A3B8"/>
+                </a:solidFill>
+              </a:rPr>
+              <a:t> descriptors.</a:t>
             </a:r>
           </a:p>
           <a:p>
@@ -6561,20 +6933,52 @@
               </a:spcAft>
             </a:pPr>
             <a:r>
-              <a:rPr b="1" sz="1200">
+              <a:rPr sz="1600" b="1" dirty="0">
                 <a:solidFill>
                   <a:srgbClr val="F8FAFC"/>
                 </a:solidFill>
               </a:rPr>
-              <a:t>• RANSAC Homography Estimation: </a:t>
-            </a:r>
-            <a:r>
-              <a:rPr sz="1200">
-                <a:solidFill>
-                  <a:srgbClr val="94A3B8"/>
-                </a:solidFill>
-              </a:rPr>
-              <a:t>Filters geometric outliers using 4-point perspective RANSAC (threshold = 5.0 px).</a:t>
+              <a:t>• RANSAC </a:t>
+            </a:r>
+            <a:r>
+              <a:rPr sz="1600" b="1" dirty="0" err="1">
+                <a:solidFill>
+                  <a:srgbClr val="F8FAFC"/>
+                </a:solidFill>
+              </a:rPr>
+              <a:t>Homography</a:t>
+            </a:r>
+            <a:r>
+              <a:rPr sz="1600" b="1" dirty="0">
+                <a:solidFill>
+                  <a:srgbClr val="F8FAFC"/>
+                </a:solidFill>
+              </a:rPr>
+              <a:t> Estimation: </a:t>
+            </a:r>
+            <a:r>
+              <a:rPr sz="1600" dirty="0">
+                <a:solidFill>
+                  <a:srgbClr val="94A3B8"/>
+                </a:solidFill>
+              </a:rPr>
+              <a:t>Filters geometric outliers using 4-point perspective RANSAC (threshold = 5.0 </a:t>
+            </a:r>
+            <a:r>
+              <a:rPr sz="1600" dirty="0" err="1">
+                <a:solidFill>
+                  <a:srgbClr val="94A3B8"/>
+                </a:solidFill>
+              </a:rPr>
+              <a:t>px</a:t>
+            </a:r>
+            <a:r>
+              <a:rPr sz="1600" dirty="0">
+                <a:solidFill>
+                  <a:srgbClr val="94A3B8"/>
+                </a:solidFill>
+              </a:rPr>
+              <a:t>).</a:t>
             </a:r>
           </a:p>
           <a:p>
@@ -6584,7 +6988,7 @@
               </a:spcAft>
             </a:pPr>
             <a:r>
-              <a:rPr b="1" sz="1200">
+              <a:rPr sz="1600" b="1" dirty="0">
                 <a:solidFill>
                   <a:srgbClr val="F8FAFC"/>
                 </a:solidFill>
@@ -6592,12 +6996,28 @@
               <a:t>• Perspective Projection: </a:t>
             </a:r>
             <a:r>
-              <a:rPr sz="1200">
-                <a:solidFill>
-                  <a:srgbClr val="94A3B8"/>
-                </a:solidFill>
-              </a:rPr>
-              <a:t>Transforms template center coordinate through homography matrix H to locate target with high confidence.</a:t>
+              <a:rPr sz="1600" dirty="0">
+                <a:solidFill>
+                  <a:srgbClr val="94A3B8"/>
+                </a:solidFill>
+              </a:rPr>
+              <a:t>Transforms template center coordinate through </a:t>
+            </a:r>
+            <a:r>
+              <a:rPr sz="1600" dirty="0" err="1">
+                <a:solidFill>
+                  <a:srgbClr val="94A3B8"/>
+                </a:solidFill>
+              </a:rPr>
+              <a:t>homography</a:t>
+            </a:r>
+            <a:r>
+              <a:rPr sz="1600" dirty="0">
+                <a:solidFill>
+                  <a:srgbClr val="94A3B8"/>
+                </a:solidFill>
+              </a:rPr>
+              <a:t> matrix H to locate target with high confidence.</a:t>
             </a:r>
           </a:p>
         </p:txBody>
@@ -6611,7 +7031,7 @@
 </file>
 
 <file path=ppt/slides/slide7.xml><?xml version="1.0" encoding="utf-8"?>
-<p:sld xmlns:a="http://schemas.openxmlformats.org/drawingml/2006/main" xmlns:p="http://schemas.openxmlformats.org/presentationml/2006/main" xmlns:r="http://schemas.openxmlformats.org/officeDocument/2006/relationships">
+<p:sld xmlns:a="http://schemas.openxmlformats.org/drawingml/2006/main" xmlns:r="http://schemas.openxmlformats.org/officeDocument/2006/relationships" xmlns:p="http://schemas.openxmlformats.org/presentationml/2006/main">
   <p:cSld>
     <p:spTree>
       <p:nvGrpSpPr>
@@ -6619,7 +7039,14 @@
         <p:cNvGrpSpPr/>
         <p:nvPr/>
       </p:nvGrpSpPr>
-      <p:grpSpPr/>
+      <p:grpSpPr>
+        <a:xfrm>
+          <a:off x="0" y="0"/>
+          <a:ext cx="0" cy="0"/>
+          <a:chOff x="0" y="0"/>
+          <a:chExt cx="0" cy="0"/>
+        </a:xfrm>
+      </p:grpSpPr>
       <p:sp>
         <p:nvSpPr>
           <p:cNvPr id="2" name="Rectangle 1"/>
@@ -6660,6 +7087,7 @@
           <a:lstStyle/>
           <a:p>
             <a:pPr algn="ctr"/>
+            <a:endParaRPr/>
           </a:p>
         </p:txBody>
       </p:sp>
@@ -6671,8 +7099,8 @@
         </p:nvSpPr>
         <p:spPr>
           <a:xfrm>
-            <a:off x="731520" y="365760"/>
-            <a:ext cx="9144000" cy="365760"/>
+            <a:off x="731520" y="411480"/>
+            <a:ext cx="9144000" cy="276999"/>
           </a:xfrm>
           <a:prstGeom prst="rect">
             <a:avLst/>
@@ -6694,6 +7122,7 @@
               </a:defRPr>
             </a:pPr>
             <a:r>
+              <a:rPr sz="1200" dirty="0"/>
               <a:t>DRIFT-SENSE / SEMICONDUCTOR ALGORITHMIC TOOLING</a:t>
             </a:r>
           </a:p>
@@ -6707,7 +7136,7 @@
         </p:nvSpPr>
         <p:spPr>
           <a:xfrm>
-            <a:off x="731520" y="640080"/>
+            <a:off x="731520" y="796789"/>
             <a:ext cx="10515600" cy="731520"/>
           </a:xfrm>
           <a:prstGeom prst="rect">
@@ -6730,6 +7159,7 @@
               </a:defRPr>
             </a:pPr>
             <a:r>
+              <a:rPr dirty="0"/>
               <a:t>Empirical Benchmark &amp; Performance Verification</a:t>
             </a:r>
           </a:p>
@@ -6777,6 +7207,7 @@
           <a:lstStyle/>
           <a:p>
             <a:pPr algn="ctr"/>
+            <a:endParaRPr/>
           </a:p>
         </p:txBody>
       </p:sp>
@@ -6820,6 +7251,7 @@
           <a:lstStyle/>
           <a:p>
             <a:pPr algn="ctr"/>
+            <a:endParaRPr/>
           </a:p>
         </p:txBody>
       </p:sp>
@@ -6832,7 +7264,7 @@
         <p:spPr>
           <a:xfrm>
             <a:off x="914400" y="1783080"/>
-            <a:ext cx="2176272" cy="1371600"/>
+            <a:ext cx="2176272" cy="959237"/>
           </a:xfrm>
           <a:prstGeom prst="rect">
             <a:avLst/>
@@ -6857,6 +7289,7 @@
               </a:defRPr>
             </a:pPr>
             <a:r>
+              <a:rPr sz="1600" dirty="0"/>
               <a:t>MEDIAN ERROR</a:t>
             </a:r>
           </a:p>
@@ -6867,15 +7300,31 @@
               </a:spcAft>
             </a:pPr>
             <a:r>
-              <a:rPr b="1" sz="1200">
+              <a:rPr sz="1600" b="1" dirty="0">
                 <a:solidFill>
                   <a:srgbClr val="F8FAFC"/>
                 </a:solidFill>
               </a:rPr>
-              <a:t>• 0.029 px: </a:t>
-            </a:r>
-            <a:r>
-              <a:rPr sz="1200">
+              <a:t>• 0.029 </a:t>
+            </a:r>
+            <a:r>
+              <a:rPr sz="1600" b="1" dirty="0" err="1">
+                <a:solidFill>
+                  <a:srgbClr val="F8FAFC"/>
+                </a:solidFill>
+              </a:rPr>
+              <a:t>px</a:t>
+            </a:r>
+            <a:r>
+              <a:rPr sz="1600" b="1" dirty="0">
+                <a:solidFill>
+                  <a:srgbClr val="F8FAFC"/>
+                </a:solidFill>
+              </a:rPr>
+              <a:t>: </a:t>
+            </a:r>
+            <a:r>
+              <a:rPr sz="1600" dirty="0">
                 <a:solidFill>
                   <a:srgbClr val="94A3B8"/>
                 </a:solidFill>
@@ -6927,6 +7376,7 @@
           <a:lstStyle/>
           <a:p>
             <a:pPr algn="ctr"/>
+            <a:endParaRPr/>
           </a:p>
         </p:txBody>
       </p:sp>
@@ -6970,6 +7420,7 @@
           <a:lstStyle/>
           <a:p>
             <a:pPr algn="ctr"/>
+            <a:endParaRPr/>
           </a:p>
         </p:txBody>
       </p:sp>
@@ -6982,7 +7433,7 @@
         <p:spPr>
           <a:xfrm>
             <a:off x="3639312" y="1783080"/>
-            <a:ext cx="2176272" cy="1371600"/>
+            <a:ext cx="2176272" cy="959237"/>
           </a:xfrm>
           <a:prstGeom prst="rect">
             <a:avLst/>
@@ -7007,6 +7458,7 @@
               </a:defRPr>
             </a:pPr>
             <a:r>
+              <a:rPr sz="1600" dirty="0"/>
               <a:t>HIT RATE (&lt; 1px)</a:t>
             </a:r>
           </a:p>
@@ -7017,7 +7469,7 @@
               </a:spcAft>
             </a:pPr>
             <a:r>
-              <a:rPr b="1" sz="1200">
+              <a:rPr sz="1600" b="1" dirty="0">
                 <a:solidFill>
                   <a:srgbClr val="F8FAFC"/>
                 </a:solidFill>
@@ -7025,7 +7477,7 @@
               <a:t>• 100.0%: </a:t>
             </a:r>
             <a:r>
-              <a:rPr sz="1200">
+              <a:rPr sz="1600" dirty="0">
                 <a:solidFill>
                   <a:srgbClr val="94A3B8"/>
                 </a:solidFill>
@@ -7077,6 +7529,7 @@
           <a:lstStyle/>
           <a:p>
             <a:pPr algn="ctr"/>
+            <a:endParaRPr/>
           </a:p>
         </p:txBody>
       </p:sp>
@@ -7120,6 +7573,7 @@
           <a:lstStyle/>
           <a:p>
             <a:pPr algn="ctr"/>
+            <a:endParaRPr/>
           </a:p>
         </p:txBody>
       </p:sp>
@@ -7132,7 +7586,7 @@
         <p:spPr>
           <a:xfrm>
             <a:off x="6364224" y="1783080"/>
-            <a:ext cx="2176272" cy="1371600"/>
+            <a:ext cx="2176272" cy="959237"/>
           </a:xfrm>
           <a:prstGeom prst="rect">
             <a:avLst/>
@@ -7157,6 +7611,7 @@
               </a:defRPr>
             </a:pPr>
             <a:r>
+              <a:rPr sz="1600" dirty="0"/>
               <a:t>HIT RATE (&lt; 5px)</a:t>
             </a:r>
           </a:p>
@@ -7167,7 +7622,7 @@
               </a:spcAft>
             </a:pPr>
             <a:r>
-              <a:rPr b="1" sz="1200">
+              <a:rPr sz="1600" b="1" dirty="0">
                 <a:solidFill>
                   <a:srgbClr val="F8FAFC"/>
                 </a:solidFill>
@@ -7175,7 +7630,7 @@
               <a:t>• 80.0%: </a:t>
             </a:r>
             <a:r>
-              <a:rPr sz="1200">
+              <a:rPr sz="1600" dirty="0">
                 <a:solidFill>
                   <a:srgbClr val="94A3B8"/>
                 </a:solidFill>
@@ -7227,6 +7682,7 @@
           <a:lstStyle/>
           <a:p>
             <a:pPr algn="ctr"/>
+            <a:endParaRPr/>
           </a:p>
         </p:txBody>
       </p:sp>
@@ -7270,6 +7726,7 @@
           <a:lstStyle/>
           <a:p>
             <a:pPr algn="ctr"/>
+            <a:endParaRPr/>
           </a:p>
         </p:txBody>
       </p:sp>
@@ -7282,7 +7739,7 @@
         <p:spPr>
           <a:xfrm>
             <a:off x="9089136" y="1783080"/>
-            <a:ext cx="2176272" cy="1371600"/>
+            <a:ext cx="2176272" cy="959237"/>
           </a:xfrm>
           <a:prstGeom prst="rect">
             <a:avLst/>
@@ -7307,6 +7764,7 @@
               </a:defRPr>
             </a:pPr>
             <a:r>
+              <a:rPr sz="1600" dirty="0"/>
               <a:t>TRAINING LATENCY</a:t>
             </a:r>
           </a:p>
@@ -7317,15 +7775,31 @@
               </a:spcAft>
             </a:pPr>
             <a:r>
-              <a:rPr b="1" sz="1200">
+              <a:rPr sz="1600" b="1" dirty="0">
                 <a:solidFill>
                   <a:srgbClr val="F8FAFC"/>
                 </a:solidFill>
               </a:rPr>
-              <a:t>• 0 ms: </a:t>
-            </a:r>
-            <a:r>
-              <a:rPr sz="1200">
+              <a:t>• 0 </a:t>
+            </a:r>
+            <a:r>
+              <a:rPr sz="1600" b="1" dirty="0" err="1">
+                <a:solidFill>
+                  <a:srgbClr val="F8FAFC"/>
+                </a:solidFill>
+              </a:rPr>
+              <a:t>ms</a:t>
+            </a:r>
+            <a:r>
+              <a:rPr sz="1600" b="1" dirty="0">
+                <a:solidFill>
+                  <a:srgbClr val="F8FAFC"/>
+                </a:solidFill>
+              </a:rPr>
+              <a:t>: </a:t>
+            </a:r>
+            <a:r>
+              <a:rPr sz="1600" dirty="0">
                 <a:solidFill>
                   <a:srgbClr val="94A3B8"/>
                 </a:solidFill>
@@ -7377,6 +7851,7 @@
           <a:lstStyle/>
           <a:p>
             <a:pPr algn="ctr"/>
+            <a:endParaRPr/>
           </a:p>
         </p:txBody>
       </p:sp>
@@ -7420,6 +7895,7 @@
           <a:lstStyle/>
           <a:p>
             <a:pPr algn="ctr"/>
+            <a:endParaRPr/>
           </a:p>
         </p:txBody>
       </p:sp>
@@ -7432,7 +7908,7 @@
         <p:spPr>
           <a:xfrm>
             <a:off x="914400" y="3611880"/>
-            <a:ext cx="10362895" cy="2468880"/>
+            <a:ext cx="10362895" cy="1682512"/>
           </a:xfrm>
           <a:prstGeom prst="rect">
             <a:avLst/>
@@ -7457,6 +7933,7 @@
               </a:defRPr>
             </a:pPr>
             <a:r>
+              <a:rPr sz="1600" dirty="0"/>
               <a:t>Benchmark Execution Results Summary (data/synthetic/ground_truth.csv)</a:t>
             </a:r>
           </a:p>
@@ -7467,7 +7944,7 @@
               </a:spcAft>
             </a:pPr>
             <a:r>
-              <a:rPr b="1" sz="1200">
+              <a:rPr sz="1600" b="1" dirty="0">
                 <a:solidFill>
                   <a:srgbClr val="F8FAFC"/>
                 </a:solidFill>
@@ -7475,12 +7952,28 @@
               <a:t>• Sample #000 (Easy Unique Pattern): </a:t>
             </a:r>
             <a:r>
-              <a:rPr sz="1200">
-                <a:solidFill>
-                  <a:srgbClr val="94A3B8"/>
-                </a:solidFill>
-              </a:rPr>
-              <a:t>True: (111.0, 221.0) | Pred: (110.9601, 221.0228) | Error: 0.046 px | Score: 0.8553</a:t>
+              <a:rPr sz="1600" dirty="0">
+                <a:solidFill>
+                  <a:srgbClr val="94A3B8"/>
+                </a:solidFill>
+              </a:rPr>
+              <a:t>True: (111.0, 221.0) | Pred: (110.9601, 221.0228) | Error: 0.046 </a:t>
+            </a:r>
+            <a:r>
+              <a:rPr sz="1600" dirty="0" err="1">
+                <a:solidFill>
+                  <a:srgbClr val="94A3B8"/>
+                </a:solidFill>
+              </a:rPr>
+              <a:t>px</a:t>
+            </a:r>
+            <a:r>
+              <a:rPr sz="1600" dirty="0">
+                <a:solidFill>
+                  <a:srgbClr val="94A3B8"/>
+                </a:solidFill>
+              </a:rPr>
+              <a:t> | Score: 0.8553</a:t>
             </a:r>
           </a:p>
           <a:p>
@@ -7490,7 +7983,7 @@
               </a:spcAft>
             </a:pPr>
             <a:r>
-              <a:rPr b="1" sz="1200">
+              <a:rPr sz="1600" b="1" dirty="0">
                 <a:solidFill>
                   <a:srgbClr val="F8FAFC"/>
                 </a:solidFill>
@@ -7498,12 +7991,28 @@
               <a:t>• Sample #015 (Easy Unique Pattern): </a:t>
             </a:r>
             <a:r>
-              <a:rPr sz="1200">
-                <a:solidFill>
-                  <a:srgbClr val="94A3B8"/>
-                </a:solidFill>
-              </a:rPr>
-              <a:t>True: (207.0, 373.0) | Pred: (207.0207, 373.0123) | Error: 0.024 px | Score: 0.8508</a:t>
+              <a:rPr sz="1600" dirty="0">
+                <a:solidFill>
+                  <a:srgbClr val="94A3B8"/>
+                </a:solidFill>
+              </a:rPr>
+              <a:t>True: (207.0, 373.0) | Pred: (207.0207, 373.0123) | Error: 0.024 </a:t>
+            </a:r>
+            <a:r>
+              <a:rPr sz="1600" dirty="0" err="1">
+                <a:solidFill>
+                  <a:srgbClr val="94A3B8"/>
+                </a:solidFill>
+              </a:rPr>
+              <a:t>px</a:t>
+            </a:r>
+            <a:r>
+              <a:rPr sz="1600" dirty="0">
+                <a:solidFill>
+                  <a:srgbClr val="94A3B8"/>
+                </a:solidFill>
+              </a:rPr>
+              <a:t> | Score: 0.8508</a:t>
             </a:r>
           </a:p>
           <a:p>
@@ -7513,7 +8022,7 @@
               </a:spcAft>
             </a:pPr>
             <a:r>
-              <a:rPr b="1" sz="1200">
+              <a:rPr sz="1600" b="1" dirty="0">
                 <a:solidFill>
                   <a:srgbClr val="F8FAFC"/>
                 </a:solidFill>
@@ -7521,12 +8030,28 @@
               <a:t>• Sample #036 (Hard Periodic Pattern): </a:t>
             </a:r>
             <a:r>
-              <a:rPr sz="1200">
-                <a:solidFill>
-                  <a:srgbClr val="94A3B8"/>
-                </a:solidFill>
-              </a:rPr>
-              <a:t>True: (432.0, 112.0) | Pred: (431.9930, 111.9910) | Error: 0.011 px | Score: 0.8548</a:t>
+              <a:rPr sz="1600" dirty="0">
+                <a:solidFill>
+                  <a:srgbClr val="94A3B8"/>
+                </a:solidFill>
+              </a:rPr>
+              <a:t>True: (432.0, 112.0) | Pred: (431.9930, 111.9910) | Error: 0.011 </a:t>
+            </a:r>
+            <a:r>
+              <a:rPr sz="1600" dirty="0" err="1">
+                <a:solidFill>
+                  <a:srgbClr val="94A3B8"/>
+                </a:solidFill>
+              </a:rPr>
+              <a:t>px</a:t>
+            </a:r>
+            <a:r>
+              <a:rPr sz="1600" dirty="0">
+                <a:solidFill>
+                  <a:srgbClr val="94A3B8"/>
+                </a:solidFill>
+              </a:rPr>
+              <a:t> | Score: 0.8548</a:t>
             </a:r>
           </a:p>
           <a:p>
@@ -7536,7 +8061,7 @@
               </a:spcAft>
             </a:pPr>
             <a:r>
-              <a:rPr b="1" sz="1200">
+              <a:rPr sz="1600" b="1" dirty="0">
                 <a:solidFill>
                   <a:srgbClr val="F8FAFC"/>
                 </a:solidFill>
@@ -7544,12 +8069,28 @@
               <a:t>• Overall Dataset Summary: </a:t>
             </a:r>
             <a:r>
-              <a:rPr sz="1200">
-                <a:solidFill>
-                  <a:srgbClr val="94A3B8"/>
-                </a:solidFill>
-              </a:rPr>
-              <a:t>40 Test Cases | Median Error: 0.029 px | Average Match Confidence: 0.845</a:t>
+              <a:rPr sz="1600" dirty="0">
+                <a:solidFill>
+                  <a:srgbClr val="94A3B8"/>
+                </a:solidFill>
+              </a:rPr>
+              <a:t>40 Test Cases | Median Error: 0.029 </a:t>
+            </a:r>
+            <a:r>
+              <a:rPr sz="1600" dirty="0" err="1">
+                <a:solidFill>
+                  <a:srgbClr val="94A3B8"/>
+                </a:solidFill>
+              </a:rPr>
+              <a:t>px</a:t>
+            </a:r>
+            <a:r>
+              <a:rPr sz="1600" dirty="0">
+                <a:solidFill>
+                  <a:srgbClr val="94A3B8"/>
+                </a:solidFill>
+              </a:rPr>
+              <a:t> | Average Match Confidence: 0.845</a:t>
             </a:r>
           </a:p>
         </p:txBody>
@@ -7563,7 +8104,7 @@
 </file>
 
 <file path=ppt/slides/slide8.xml><?xml version="1.0" encoding="utf-8"?>
-<p:sld xmlns:a="http://schemas.openxmlformats.org/drawingml/2006/main" xmlns:p="http://schemas.openxmlformats.org/presentationml/2006/main" xmlns:r="http://schemas.openxmlformats.org/officeDocument/2006/relationships">
+<p:sld xmlns:a="http://schemas.openxmlformats.org/drawingml/2006/main" xmlns:r="http://schemas.openxmlformats.org/officeDocument/2006/relationships" xmlns:p="http://schemas.openxmlformats.org/presentationml/2006/main">
   <p:cSld>
     <p:spTree>
       <p:nvGrpSpPr>
@@ -7571,7 +8112,14 @@
         <p:cNvGrpSpPr/>
         <p:nvPr/>
       </p:nvGrpSpPr>
-      <p:grpSpPr/>
+      <p:grpSpPr>
+        <a:xfrm>
+          <a:off x="0" y="0"/>
+          <a:ext cx="0" cy="0"/>
+          <a:chOff x="0" y="0"/>
+          <a:chExt cx="0" cy="0"/>
+        </a:xfrm>
+      </p:grpSpPr>
       <p:sp>
         <p:nvSpPr>
           <p:cNvPr id="2" name="Rectangle 1"/>
@@ -7612,6 +8160,7 @@
           <a:lstStyle/>
           <a:p>
             <a:pPr algn="ctr"/>
+            <a:endParaRPr/>
           </a:p>
         </p:txBody>
       </p:sp>
@@ -7623,8 +8172,8 @@
         </p:nvSpPr>
         <p:spPr>
           <a:xfrm>
-            <a:off x="731520" y="365760"/>
-            <a:ext cx="9144000" cy="365760"/>
+            <a:off x="731520" y="504259"/>
+            <a:ext cx="9144000" cy="276999"/>
           </a:xfrm>
           <a:prstGeom prst="rect">
             <a:avLst/>
@@ -7646,6 +8195,7 @@
               </a:defRPr>
             </a:pPr>
             <a:r>
+              <a:rPr sz="1200" dirty="0"/>
               <a:t>DRIFT-SENSE / SEMICONDUCTOR ALGORITHMIC TOOLING</a:t>
             </a:r>
           </a:p>
@@ -7659,7 +8209,7 @@
         </p:nvSpPr>
         <p:spPr>
           <a:xfrm>
-            <a:off x="731520" y="640080"/>
+            <a:off x="731520" y="778579"/>
             <a:ext cx="10515600" cy="731520"/>
           </a:xfrm>
           <a:prstGeom prst="rect">
@@ -7682,7 +8232,8 @@
               </a:defRPr>
             </a:pPr>
             <a:r>
-              <a:t>Technical Presentation Walkthrough &amp; Live Demo</a:t>
+              <a:rPr dirty="0"/>
+              <a:t>Conclusion &amp; Future Hardware Roadmap</a:t>
             </a:r>
           </a:p>
         </p:txBody>
@@ -7696,7 +8247,7 @@
         <p:spPr>
           <a:xfrm>
             <a:off x="731520" y="1645920"/>
-            <a:ext cx="5175504" cy="4572000"/>
+            <a:ext cx="3328416" cy="4572000"/>
           </a:xfrm>
           <a:prstGeom prst="roundRect">
             <a:avLst/>
@@ -7729,6 +8280,7 @@
           <a:lstStyle/>
           <a:p>
             <a:pPr algn="ctr"/>
+            <a:endParaRPr/>
           </a:p>
         </p:txBody>
       </p:sp>
@@ -7741,13 +8293,13 @@
         <p:spPr>
           <a:xfrm>
             <a:off x="731520" y="1645920"/>
-            <a:ext cx="5175504" cy="73152"/>
+            <a:ext cx="3328416" cy="73152"/>
           </a:xfrm>
           <a:prstGeom prst="rect">
             <a:avLst/>
           </a:prstGeom>
           <a:solidFill>
-            <a:srgbClr val="0EA5E9"/>
+            <a:srgbClr val="10B981"/>
           </a:solidFill>
           <a:ln>
             <a:noFill/>
@@ -7772,6 +8324,7 @@
           <a:lstStyle/>
           <a:p>
             <a:pPr algn="ctr"/>
+            <a:endParaRPr/>
           </a:p>
         </p:txBody>
       </p:sp>
@@ -7784,7 +8337,7 @@
         <p:spPr>
           <a:xfrm>
             <a:off x="914400" y="1783080"/>
-            <a:ext cx="4809744" cy="4297680"/>
+            <a:ext cx="2962656" cy="2344231"/>
           </a:xfrm>
           <a:prstGeom prst="rect">
             <a:avLst/>
@@ -7803,13 +8356,14 @@
               </a:spcAft>
               <a:defRPr sz="1600" b="1">
                 <a:solidFill>
-                  <a:srgbClr val="0EA5E9"/>
+                  <a:srgbClr val="10B981"/>
                 </a:solidFill>
                 <a:latin typeface="Segoe UI"/>
               </a:defRPr>
             </a:pPr>
             <a:r>
-              <a:t>Demo Video Structure (3-Minute Segment)</a:t>
+              <a:rPr sz="1600" dirty="0"/>
+              <a:t>1. Production Ready</a:t>
             </a:r>
           </a:p>
           <a:p>
@@ -7819,20 +8373,20 @@
               </a:spcAft>
             </a:pPr>
             <a:r>
-              <a:rPr b="1" sz="1200">
+              <a:rPr sz="1600" b="1" dirty="0">
                 <a:solidFill>
                   <a:srgbClr val="F8FAFC"/>
                 </a:solidFill>
               </a:rPr>
-              <a:t>• Segment 1 (0:00 - 0:45): </a:t>
-            </a:r>
-            <a:r>
-              <a:rPr sz="1200">
-                <a:solidFill>
-                  <a:srgbClr val="94A3B8"/>
-                </a:solidFill>
-              </a:rPr>
-              <a:t>Introduction &amp; Wafer Inspection Stage Drift Problem Context.</a:t>
+              <a:t>• High Accuracy: </a:t>
+            </a:r>
+            <a:r>
+              <a:rPr sz="1600" dirty="0">
+                <a:solidFill>
+                  <a:srgbClr val="94A3B8"/>
+                </a:solidFill>
+              </a:rPr>
+              <a:t>Median positioning error of 0.029 pixels.</a:t>
             </a:r>
           </a:p>
           <a:p>
@@ -7842,20 +8396,20 @@
               </a:spcAft>
             </a:pPr>
             <a:r>
-              <a:rPr b="1" sz="1200">
+              <a:rPr sz="1600" b="1" dirty="0">
                 <a:solidFill>
                   <a:srgbClr val="F8FAFC"/>
                 </a:solidFill>
               </a:rPr>
-              <a:t>• Segment 2 (0:45 - 1:30): </a:t>
-            </a:r>
-            <a:r>
-              <a:rPr sz="1200">
-                <a:solidFill>
-                  <a:srgbClr val="94A3B8"/>
-                </a:solidFill>
-              </a:rPr>
-              <a:t>Preprocessing &amp; Pyramidal Multi-Scale Search Walkthrough.</a:t>
+              <a:t>• Sub-Pixel Resolution: </a:t>
+            </a:r>
+            <a:r>
+              <a:rPr sz="1600" dirty="0">
+                <a:solidFill>
+                  <a:srgbClr val="94A3B8"/>
+                </a:solidFill>
+              </a:rPr>
+              <a:t>Resolves sub-15nm displacement.</a:t>
             </a:r>
           </a:p>
           <a:p>
@@ -7865,43 +8419,20 @@
               </a:spcAft>
             </a:pPr>
             <a:r>
-              <a:rPr b="1" sz="1200">
+              <a:rPr sz="1600" b="1" dirty="0">
                 <a:solidFill>
                   <a:srgbClr val="F8FAFC"/>
                 </a:solidFill>
               </a:rPr>
-              <a:t>• Segment 3 (1:30 - 2:20): </a:t>
-            </a:r>
-            <a:r>
-              <a:rPr sz="1200">
-                <a:solidFill>
-                  <a:srgbClr val="94A3B8"/>
-                </a:solidFill>
-              </a:rPr>
-              <a:t>NMS Peak Detection, Periodicity Tie-Breaking &amp; Sub-Pixel Parabolic Fit.</a:t>
-            </a:r>
-          </a:p>
-          <a:p>
-            <a:pPr>
-              <a:spcAft>
-                <a:spcPts val="600"/>
-              </a:spcAft>
-            </a:pPr>
-            <a:r>
-              <a:rPr b="1" sz="1200">
-                <a:solidFill>
-                  <a:srgbClr val="F8FAFC"/>
-                </a:solidFill>
-              </a:rPr>
-              <a:t>• Segment 4 (2:20 - 3:00): </a:t>
-            </a:r>
-            <a:r>
-              <a:rPr sz="1200">
-                <a:solidFill>
-                  <a:srgbClr val="94A3B8"/>
-                </a:solidFill>
-              </a:rPr>
-              <a:t>ORB+RANSAC AI Fallback &amp; Benchmark Metrics Review.</a:t>
+              <a:t>• Zero Training Cost: </a:t>
+            </a:r>
+            <a:r>
+              <a:rPr sz="1600" dirty="0">
+                <a:solidFill>
+                  <a:srgbClr val="94A3B8"/>
+                </a:solidFill>
+              </a:rPr>
+              <a:t>Instant deployment without model weights.</a:t>
             </a:r>
           </a:p>
         </p:txBody>
@@ -7914,8 +8445,8 @@
         </p:nvSpPr>
         <p:spPr>
           <a:xfrm>
-            <a:off x="6272784" y="1645920"/>
-            <a:ext cx="5175504" cy="4572000"/>
+            <a:off x="4425696" y="1645920"/>
+            <a:ext cx="3328416" cy="4572000"/>
           </a:xfrm>
           <a:prstGeom prst="roundRect">
             <a:avLst/>
@@ -7948,6 +8479,7 @@
           <a:lstStyle/>
           <a:p>
             <a:pPr algn="ctr"/>
+            <a:endParaRPr/>
           </a:p>
         </p:txBody>
       </p:sp>
@@ -7959,14 +8491,14 @@
         </p:nvSpPr>
         <p:spPr>
           <a:xfrm>
-            <a:off x="6272784" y="1645920"/>
-            <a:ext cx="5175504" cy="73152"/>
+            <a:off x="4425696" y="1645920"/>
+            <a:ext cx="3328416" cy="73152"/>
           </a:xfrm>
           <a:prstGeom prst="rect">
             <a:avLst/>
           </a:prstGeom>
           <a:solidFill>
-            <a:srgbClr val="8B5CF6"/>
+            <a:srgbClr val="0EA5E9"/>
           </a:solidFill>
           <a:ln>
             <a:noFill/>
@@ -7991,6 +8523,7 @@
           <a:lstStyle/>
           <a:p>
             <a:pPr algn="ctr"/>
+            <a:endParaRPr/>
           </a:p>
         </p:txBody>
       </p:sp>
@@ -8002,8 +8535,8 @@
         </p:nvSpPr>
         <p:spPr>
           <a:xfrm>
-            <a:off x="6455664" y="1783080"/>
-            <a:ext cx="4809744" cy="4297680"/>
+            <a:off x="4608576" y="1783080"/>
+            <a:ext cx="2962656" cy="2098010"/>
           </a:xfrm>
           <a:prstGeom prst="rect">
             <a:avLst/>
@@ -8022,13 +8555,14 @@
               </a:spcAft>
               <a:defRPr sz="1600" b="1">
                 <a:solidFill>
-                  <a:srgbClr val="8B5CF6"/>
+                  <a:srgbClr val="0EA5E9"/>
                 </a:solidFill>
                 <a:latin typeface="Segoe UI"/>
               </a:defRPr>
             </a:pPr>
             <a:r>
-              <a:t>Technical Q&amp;A Preparation</a:t>
+              <a:rPr sz="1600" dirty="0"/>
+              <a:t>2. Robust Engineering</a:t>
             </a:r>
           </a:p>
           <a:p>
@@ -8038,20 +8572,20 @@
               </a:spcAft>
             </a:pPr>
             <a:r>
-              <a:rPr b="1" sz="1200">
+              <a:rPr sz="1600" b="1" dirty="0">
                 <a:solidFill>
                   <a:srgbClr val="F8FAFC"/>
                 </a:solidFill>
               </a:rPr>
-              <a:t>• Q1: Why NCC over Standard Matching?: </a:t>
-            </a:r>
-            <a:r>
-              <a:rPr sz="1200">
-                <a:solidFill>
-                  <a:srgbClr val="94A3B8"/>
-                </a:solidFill>
-              </a:rPr>
-              <a:t>NCC is invariant to linear intensity scaling (I -&gt; aI + b), preserving accuracy under optical lighting shifts.</a:t>
+              <a:t>• Multi-Scale Pyramid: </a:t>
+            </a:r>
+            <a:r>
+              <a:rPr sz="1600" dirty="0">
+                <a:solidFill>
+                  <a:srgbClr val="94A3B8"/>
+                </a:solidFill>
+              </a:rPr>
+              <a:t>Handles magnification drift.</a:t>
             </a:r>
           </a:p>
           <a:p>
@@ -8061,20 +8595,20 @@
               </a:spcAft>
             </a:pPr>
             <a:r>
-              <a:rPr b="1" sz="1200">
+              <a:rPr sz="1600" b="1" dirty="0">
                 <a:solidFill>
                   <a:srgbClr val="F8FAFC"/>
                 </a:solidFill>
               </a:rPr>
-              <a:t>• Q2: How does Sub-Pixel Fitting work?: </a:t>
-            </a:r>
-            <a:r>
-              <a:rPr sz="1200">
-                <a:solidFill>
-                  <a:srgbClr val="94A3B8"/>
-                </a:solidFill>
-              </a:rPr>
-              <a:t>Extracts 3x3 correlation matrix around integer peak and computes 1D quadratic offsets along X and Y axes.</a:t>
+              <a:t>• Periodicity Prior: </a:t>
+            </a:r>
+            <a:r>
+              <a:rPr sz="1600" dirty="0">
+                <a:solidFill>
+                  <a:srgbClr val="94A3B8"/>
+                </a:solidFill>
+              </a:rPr>
+              <a:t>Resolves repeating memory arrays.</a:t>
             </a:r>
           </a:p>
           <a:p>
@@ -8084,166 +8618,33 @@
               </a:spcAft>
             </a:pPr>
             <a:r>
-              <a:rPr b="1" sz="1200">
+              <a:rPr sz="1600" b="1" dirty="0">
                 <a:solidFill>
                   <a:srgbClr val="F8FAFC"/>
                 </a:solidFill>
               </a:rPr>
-              <a:t>• Q3: How are Non-Linear Distortions handled?: </a:t>
-            </a:r>
-            <a:r>
-              <a:rPr sz="1200">
-                <a:solidFill>
-                  <a:srgbClr val="94A3B8"/>
-                </a:solidFill>
-              </a:rPr>
-              <a:t>ORB keypoints + RANSAC homography project template center coordinates through affine/perspective space.</a:t>
-            </a:r>
-          </a:p>
-        </p:txBody>
-      </p:sp>
-    </p:spTree>
-  </p:cSld>
-  <p:clrMapOvr>
-    <a:masterClrMapping/>
-  </p:clrMapOvr>
-</p:sld>
-</file>
-
-<file path=ppt/slides/slide9.xml><?xml version="1.0" encoding="utf-8"?>
-<p:sld xmlns:a="http://schemas.openxmlformats.org/drawingml/2006/main" xmlns:p="http://schemas.openxmlformats.org/presentationml/2006/main" xmlns:r="http://schemas.openxmlformats.org/officeDocument/2006/relationships">
-  <p:cSld>
-    <p:spTree>
-      <p:nvGrpSpPr>
-        <p:cNvPr id="1" name=""/>
-        <p:cNvGrpSpPr/>
-        <p:nvPr/>
-      </p:nvGrpSpPr>
-      <p:grpSpPr/>
-      <p:sp>
-        <p:nvSpPr>
-          <p:cNvPr id="2" name="Rectangle 1"/>
+              <a:t>• AI Fallback: </a:t>
+            </a:r>
+            <a:r>
+              <a:rPr sz="1600" dirty="0">
+                <a:solidFill>
+                  <a:srgbClr val="94A3B8"/>
+                </a:solidFill>
+              </a:rPr>
+              <a:t>Recovers from heavy optical noise.</a:t>
+            </a:r>
+          </a:p>
+        </p:txBody>
+      </p:sp>
+      <p:sp>
+        <p:nvSpPr>
+          <p:cNvPr id="11" name="Rounded Rectangle 10"/>
           <p:cNvSpPr/>
           <p:nvPr/>
         </p:nvSpPr>
         <p:spPr>
           <a:xfrm>
-            <a:off x="0" y="0"/>
-            <a:ext cx="12191695" cy="6858000"/>
-          </a:xfrm>
-          <a:prstGeom prst="rect">
-            <a:avLst/>
-          </a:prstGeom>
-          <a:solidFill>
-            <a:srgbClr val="0F172A"/>
-          </a:solidFill>
-          <a:ln>
-            <a:noFill/>
-          </a:ln>
-        </p:spPr>
-        <p:style>
-          <a:lnRef idx="1">
-            <a:schemeClr val="accent1"/>
-          </a:lnRef>
-          <a:fillRef idx="3">
-            <a:schemeClr val="accent1"/>
-          </a:fillRef>
-          <a:effectRef idx="2">
-            <a:schemeClr val="accent1"/>
-          </a:effectRef>
-          <a:fontRef idx="minor">
-            <a:schemeClr val="lt1"/>
-          </a:fontRef>
-        </p:style>
-        <p:txBody>
-          <a:bodyPr rtlCol="0" anchor="ctr"/>
-          <a:lstStyle/>
-          <a:p>
-            <a:pPr algn="ctr"/>
-          </a:p>
-        </p:txBody>
-      </p:sp>
-      <p:sp>
-        <p:nvSpPr>
-          <p:cNvPr id="3" name="TextBox 2"/>
-          <p:cNvSpPr txBox="1"/>
-          <p:nvPr/>
-        </p:nvSpPr>
-        <p:spPr>
-          <a:xfrm>
-            <a:off x="731520" y="365760"/>
-            <a:ext cx="9144000" cy="365760"/>
-          </a:xfrm>
-          <a:prstGeom prst="rect">
-            <a:avLst/>
-          </a:prstGeom>
-          <a:noFill/>
-        </p:spPr>
-        <p:txBody>
-          <a:bodyPr wrap="square">
-            <a:spAutoFit/>
-          </a:bodyPr>
-          <a:lstStyle/>
-          <a:p>
-            <a:pPr>
-              <a:defRPr sz="1000" b="1">
-                <a:solidFill>
-                  <a:srgbClr val="0EA5E9"/>
-                </a:solidFill>
-                <a:latin typeface="Segoe UI"/>
-              </a:defRPr>
-            </a:pPr>
-            <a:r>
-              <a:t>DRIFT-SENSE / SEMICONDUCTOR ALGORITHMIC TOOLING</a:t>
-            </a:r>
-          </a:p>
-        </p:txBody>
-      </p:sp>
-      <p:sp>
-        <p:nvSpPr>
-          <p:cNvPr id="4" name="TextBox 3"/>
-          <p:cNvSpPr txBox="1"/>
-          <p:nvPr/>
-        </p:nvSpPr>
-        <p:spPr>
-          <a:xfrm>
-            <a:off x="731520" y="640080"/>
-            <a:ext cx="10515600" cy="731520"/>
-          </a:xfrm>
-          <a:prstGeom prst="rect">
-            <a:avLst/>
-          </a:prstGeom>
-          <a:noFill/>
-        </p:spPr>
-        <p:txBody>
-          <a:bodyPr wrap="square">
-            <a:spAutoFit/>
-          </a:bodyPr>
-          <a:lstStyle/>
-          <a:p>
-            <a:pPr>
-              <a:defRPr sz="2600" b="1">
-                <a:solidFill>
-                  <a:srgbClr val="F8FAFC"/>
-                </a:solidFill>
-                <a:latin typeface="Segoe UI"/>
-              </a:defRPr>
-            </a:pPr>
-            <a:r>
-              <a:t>Conclusion &amp; Future Hardware Roadmap</a:t>
-            </a:r>
-          </a:p>
-        </p:txBody>
-      </p:sp>
-      <p:sp>
-        <p:nvSpPr>
-          <p:cNvPr id="5" name="Rounded Rectangle 4"/>
-          <p:cNvSpPr/>
-          <p:nvPr/>
-        </p:nvSpPr>
-        <p:spPr>
-          <a:xfrm>
-            <a:off x="731520" y="1645920"/>
+            <a:off x="8119872" y="1645920"/>
             <a:ext cx="3328416" cy="4572000"/>
           </a:xfrm>
           <a:prstGeom prst="roundRect">
@@ -8277,398 +8678,7 @@
           <a:lstStyle/>
           <a:p>
             <a:pPr algn="ctr"/>
-          </a:p>
-        </p:txBody>
-      </p:sp>
-      <p:sp>
-        <p:nvSpPr>
-          <p:cNvPr id="6" name="Rectangle 5"/>
-          <p:cNvSpPr/>
-          <p:nvPr/>
-        </p:nvSpPr>
-        <p:spPr>
-          <a:xfrm>
-            <a:off x="731520" y="1645920"/>
-            <a:ext cx="3328416" cy="73152"/>
-          </a:xfrm>
-          <a:prstGeom prst="rect">
-            <a:avLst/>
-          </a:prstGeom>
-          <a:solidFill>
-            <a:srgbClr val="10B981"/>
-          </a:solidFill>
-          <a:ln>
-            <a:noFill/>
-          </a:ln>
-        </p:spPr>
-        <p:style>
-          <a:lnRef idx="1">
-            <a:schemeClr val="accent1"/>
-          </a:lnRef>
-          <a:fillRef idx="3">
-            <a:schemeClr val="accent1"/>
-          </a:fillRef>
-          <a:effectRef idx="2">
-            <a:schemeClr val="accent1"/>
-          </a:effectRef>
-          <a:fontRef idx="minor">
-            <a:schemeClr val="lt1"/>
-          </a:fontRef>
-        </p:style>
-        <p:txBody>
-          <a:bodyPr rtlCol="0" anchor="ctr"/>
-          <a:lstStyle/>
-          <a:p>
-            <a:pPr algn="ctr"/>
-          </a:p>
-        </p:txBody>
-      </p:sp>
-      <p:sp>
-        <p:nvSpPr>
-          <p:cNvPr id="7" name="TextBox 6"/>
-          <p:cNvSpPr txBox="1"/>
-          <p:nvPr/>
-        </p:nvSpPr>
-        <p:spPr>
-          <a:xfrm>
-            <a:off x="914400" y="1783080"/>
-            <a:ext cx="2962656" cy="4297680"/>
-          </a:xfrm>
-          <a:prstGeom prst="rect">
-            <a:avLst/>
-          </a:prstGeom>
-          <a:noFill/>
-        </p:spPr>
-        <p:txBody>
-          <a:bodyPr wrap="square">
-            <a:spAutoFit/>
-          </a:bodyPr>
-          <a:lstStyle/>
-          <a:p>
-            <a:pPr>
-              <a:spcAft>
-                <a:spcPts val="1000"/>
-              </a:spcAft>
-              <a:defRPr sz="1600" b="1">
-                <a:solidFill>
-                  <a:srgbClr val="10B981"/>
-                </a:solidFill>
-                <a:latin typeface="Segoe UI"/>
-              </a:defRPr>
-            </a:pPr>
-            <a:r>
-              <a:t>1. Production Ready</a:t>
-            </a:r>
-          </a:p>
-          <a:p>
-            <a:pPr>
-              <a:spcAft>
-                <a:spcPts val="600"/>
-              </a:spcAft>
-            </a:pPr>
-            <a:r>
-              <a:rPr b="1" sz="1200">
-                <a:solidFill>
-                  <a:srgbClr val="F8FAFC"/>
-                </a:solidFill>
-              </a:rPr>
-              <a:t>• High Accuracy: </a:t>
-            </a:r>
-            <a:r>
-              <a:rPr sz="1200">
-                <a:solidFill>
-                  <a:srgbClr val="94A3B8"/>
-                </a:solidFill>
-              </a:rPr>
-              <a:t>Median positioning error of 0.029 pixels.</a:t>
-            </a:r>
-          </a:p>
-          <a:p>
-            <a:pPr>
-              <a:spcAft>
-                <a:spcPts val="600"/>
-              </a:spcAft>
-            </a:pPr>
-            <a:r>
-              <a:rPr b="1" sz="1200">
-                <a:solidFill>
-                  <a:srgbClr val="F8FAFC"/>
-                </a:solidFill>
-              </a:rPr>
-              <a:t>• Sub-Pixel Resolution: </a:t>
-            </a:r>
-            <a:r>
-              <a:rPr sz="1200">
-                <a:solidFill>
-                  <a:srgbClr val="94A3B8"/>
-                </a:solidFill>
-              </a:rPr>
-              <a:t>Resolves sub-15nm displacement.</a:t>
-            </a:r>
-          </a:p>
-          <a:p>
-            <a:pPr>
-              <a:spcAft>
-                <a:spcPts val="600"/>
-              </a:spcAft>
-            </a:pPr>
-            <a:r>
-              <a:rPr b="1" sz="1200">
-                <a:solidFill>
-                  <a:srgbClr val="F8FAFC"/>
-                </a:solidFill>
-              </a:rPr>
-              <a:t>• Zero Training Cost: </a:t>
-            </a:r>
-            <a:r>
-              <a:rPr sz="1200">
-                <a:solidFill>
-                  <a:srgbClr val="94A3B8"/>
-                </a:solidFill>
-              </a:rPr>
-              <a:t>Instant deployment without model weights.</a:t>
-            </a:r>
-          </a:p>
-        </p:txBody>
-      </p:sp>
-      <p:sp>
-        <p:nvSpPr>
-          <p:cNvPr id="8" name="Rounded Rectangle 7"/>
-          <p:cNvSpPr/>
-          <p:nvPr/>
-        </p:nvSpPr>
-        <p:spPr>
-          <a:xfrm>
-            <a:off x="4425696" y="1645920"/>
-            <a:ext cx="3328416" cy="4572000"/>
-          </a:xfrm>
-          <a:prstGeom prst="roundRect">
-            <a:avLst/>
-          </a:prstGeom>
-          <a:solidFill>
-            <a:srgbClr val="1E293B"/>
-          </a:solidFill>
-          <a:ln w="19050">
-            <a:solidFill>
-              <a:srgbClr val="334155"/>
-            </a:solidFill>
-          </a:ln>
-        </p:spPr>
-        <p:style>
-          <a:lnRef idx="1">
-            <a:schemeClr val="accent1"/>
-          </a:lnRef>
-          <a:fillRef idx="3">
-            <a:schemeClr val="accent1"/>
-          </a:fillRef>
-          <a:effectRef idx="2">
-            <a:schemeClr val="accent1"/>
-          </a:effectRef>
-          <a:fontRef idx="minor">
-            <a:schemeClr val="lt1"/>
-          </a:fontRef>
-        </p:style>
-        <p:txBody>
-          <a:bodyPr rtlCol="0" anchor="ctr"/>
-          <a:lstStyle/>
-          <a:p>
-            <a:pPr algn="ctr"/>
-          </a:p>
-        </p:txBody>
-      </p:sp>
-      <p:sp>
-        <p:nvSpPr>
-          <p:cNvPr id="9" name="Rectangle 8"/>
-          <p:cNvSpPr/>
-          <p:nvPr/>
-        </p:nvSpPr>
-        <p:spPr>
-          <a:xfrm>
-            <a:off x="4425696" y="1645920"/>
-            <a:ext cx="3328416" cy="73152"/>
-          </a:xfrm>
-          <a:prstGeom prst="rect">
-            <a:avLst/>
-          </a:prstGeom>
-          <a:solidFill>
-            <a:srgbClr val="0EA5E9"/>
-          </a:solidFill>
-          <a:ln>
-            <a:noFill/>
-          </a:ln>
-        </p:spPr>
-        <p:style>
-          <a:lnRef idx="1">
-            <a:schemeClr val="accent1"/>
-          </a:lnRef>
-          <a:fillRef idx="3">
-            <a:schemeClr val="accent1"/>
-          </a:fillRef>
-          <a:effectRef idx="2">
-            <a:schemeClr val="accent1"/>
-          </a:effectRef>
-          <a:fontRef idx="minor">
-            <a:schemeClr val="lt1"/>
-          </a:fontRef>
-        </p:style>
-        <p:txBody>
-          <a:bodyPr rtlCol="0" anchor="ctr"/>
-          <a:lstStyle/>
-          <a:p>
-            <a:pPr algn="ctr"/>
-          </a:p>
-        </p:txBody>
-      </p:sp>
-      <p:sp>
-        <p:nvSpPr>
-          <p:cNvPr id="10" name="TextBox 9"/>
-          <p:cNvSpPr txBox="1"/>
-          <p:nvPr/>
-        </p:nvSpPr>
-        <p:spPr>
-          <a:xfrm>
-            <a:off x="4608576" y="1783080"/>
-            <a:ext cx="2962656" cy="4297680"/>
-          </a:xfrm>
-          <a:prstGeom prst="rect">
-            <a:avLst/>
-          </a:prstGeom>
-          <a:noFill/>
-        </p:spPr>
-        <p:txBody>
-          <a:bodyPr wrap="square">
-            <a:spAutoFit/>
-          </a:bodyPr>
-          <a:lstStyle/>
-          <a:p>
-            <a:pPr>
-              <a:spcAft>
-                <a:spcPts val="1000"/>
-              </a:spcAft>
-              <a:defRPr sz="1600" b="1">
-                <a:solidFill>
-                  <a:srgbClr val="0EA5E9"/>
-                </a:solidFill>
-                <a:latin typeface="Segoe UI"/>
-              </a:defRPr>
-            </a:pPr>
-            <a:r>
-              <a:t>2. Robust Engineering</a:t>
-            </a:r>
-          </a:p>
-          <a:p>
-            <a:pPr>
-              <a:spcAft>
-                <a:spcPts val="600"/>
-              </a:spcAft>
-            </a:pPr>
-            <a:r>
-              <a:rPr b="1" sz="1200">
-                <a:solidFill>
-                  <a:srgbClr val="F8FAFC"/>
-                </a:solidFill>
-              </a:rPr>
-              <a:t>• Multi-Scale Pyramid: </a:t>
-            </a:r>
-            <a:r>
-              <a:rPr sz="1200">
-                <a:solidFill>
-                  <a:srgbClr val="94A3B8"/>
-                </a:solidFill>
-              </a:rPr>
-              <a:t>Handles magnification drift.</a:t>
-            </a:r>
-          </a:p>
-          <a:p>
-            <a:pPr>
-              <a:spcAft>
-                <a:spcPts val="600"/>
-              </a:spcAft>
-            </a:pPr>
-            <a:r>
-              <a:rPr b="1" sz="1200">
-                <a:solidFill>
-                  <a:srgbClr val="F8FAFC"/>
-                </a:solidFill>
-              </a:rPr>
-              <a:t>• Periodicity Prior: </a:t>
-            </a:r>
-            <a:r>
-              <a:rPr sz="1200">
-                <a:solidFill>
-                  <a:srgbClr val="94A3B8"/>
-                </a:solidFill>
-              </a:rPr>
-              <a:t>Resolves repeating memory arrays.</a:t>
-            </a:r>
-          </a:p>
-          <a:p>
-            <a:pPr>
-              <a:spcAft>
-                <a:spcPts val="600"/>
-              </a:spcAft>
-            </a:pPr>
-            <a:r>
-              <a:rPr b="1" sz="1200">
-                <a:solidFill>
-                  <a:srgbClr val="F8FAFC"/>
-                </a:solidFill>
-              </a:rPr>
-              <a:t>• AI Fallback: </a:t>
-            </a:r>
-            <a:r>
-              <a:rPr sz="1200">
-                <a:solidFill>
-                  <a:srgbClr val="94A3B8"/>
-                </a:solidFill>
-              </a:rPr>
-              <a:t>Recovers from heavy optical noise.</a:t>
-            </a:r>
-          </a:p>
-        </p:txBody>
-      </p:sp>
-      <p:sp>
-        <p:nvSpPr>
-          <p:cNvPr id="11" name="Rounded Rectangle 10"/>
-          <p:cNvSpPr/>
-          <p:nvPr/>
-        </p:nvSpPr>
-        <p:spPr>
-          <a:xfrm>
-            <a:off x="8119872" y="1645920"/>
-            <a:ext cx="3328416" cy="4572000"/>
-          </a:xfrm>
-          <a:prstGeom prst="roundRect">
-            <a:avLst/>
-          </a:prstGeom>
-          <a:solidFill>
-            <a:srgbClr val="1E293B"/>
-          </a:solidFill>
-          <a:ln w="19050">
-            <a:solidFill>
-              <a:srgbClr val="334155"/>
-            </a:solidFill>
-          </a:ln>
-        </p:spPr>
-        <p:style>
-          <a:lnRef idx="1">
-            <a:schemeClr val="accent1"/>
-          </a:lnRef>
-          <a:fillRef idx="3">
-            <a:schemeClr val="accent1"/>
-          </a:fillRef>
-          <a:effectRef idx="2">
-            <a:schemeClr val="accent1"/>
-          </a:effectRef>
-          <a:fontRef idx="minor">
-            <a:schemeClr val="lt1"/>
-          </a:fontRef>
-        </p:style>
-        <p:txBody>
-          <a:bodyPr rtlCol="0" anchor="ctr"/>
-          <a:lstStyle/>
-          <a:p>
-            <a:pPr algn="ctr"/>
+            <a:endParaRPr/>
           </a:p>
         </p:txBody>
       </p:sp>
@@ -8712,6 +8722,7 @@
           <a:lstStyle/>
           <a:p>
             <a:pPr algn="ctr"/>
+            <a:endParaRPr/>
           </a:p>
         </p:txBody>
       </p:sp>
@@ -8724,7 +8735,7 @@
         <p:spPr>
           <a:xfrm>
             <a:off x="8302752" y="1783080"/>
-            <a:ext cx="2962656" cy="4297680"/>
+            <a:ext cx="2962656" cy="2836674"/>
           </a:xfrm>
           <a:prstGeom prst="rect">
             <a:avLst/>
@@ -8749,6 +8760,7 @@
               </a:defRPr>
             </a:pPr>
             <a:r>
+              <a:rPr sz="1600" dirty="0"/>
               <a:t>3. Future Acceleration</a:t>
             </a:r>
           </a:p>
@@ -8759,7 +8771,7 @@
               </a:spcAft>
             </a:pPr>
             <a:r>
-              <a:rPr b="1" sz="1200">
+              <a:rPr sz="1600" b="1" dirty="0">
                 <a:solidFill>
                   <a:srgbClr val="F8FAFC"/>
                 </a:solidFill>
@@ -8767,7 +8779,7 @@
               <a:t>• FPGA / ASIC IP: </a:t>
             </a:r>
             <a:r>
-              <a:rPr sz="1200">
+              <a:rPr sz="1600" dirty="0">
                 <a:solidFill>
                   <a:srgbClr val="94A3B8"/>
                 </a:solidFill>
@@ -8782,7 +8794,7 @@
               </a:spcAft>
             </a:pPr>
             <a:r>
-              <a:rPr b="1" sz="1200">
+              <a:rPr sz="1600" b="1" dirty="0">
                 <a:solidFill>
                   <a:srgbClr val="F8FAFC"/>
                 </a:solidFill>
@@ -8790,7 +8802,7 @@
               <a:t>• Sub-Graph Super-Res: </a:t>
             </a:r>
             <a:r>
-              <a:rPr sz="1200">
+              <a:rPr sz="1600" dirty="0">
                 <a:solidFill>
                   <a:srgbClr val="94A3B8"/>
                 </a:solidFill>
@@ -8805,7 +8817,7 @@
               </a:spcAft>
             </a:pPr>
             <a:r>
-              <a:rPr b="1" sz="1200">
+              <a:rPr sz="1600" b="1" dirty="0">
                 <a:solidFill>
                   <a:srgbClr val="F8FAFC"/>
                 </a:solidFill>
@@ -8813,7 +8825,7 @@
               <a:t>• Multi-Die Alignment: </a:t>
             </a:r>
             <a:r>
-              <a:rPr sz="1200">
+              <a:rPr sz="1600" dirty="0">
                 <a:solidFill>
                   <a:srgbClr val="94A3B8"/>
                 </a:solidFill>
@@ -9146,6 +9158,24 @@
         </a:fontRef>
       </a:style>
     </a:lnDef>
+    <a:txDef>
+      <a:spPr>
+        <a:noFill/>
+      </a:spPr>
+      <a:bodyPr wrap="square">
+        <a:spAutoFit/>
+      </a:bodyPr>
+      <a:lstStyle>
+        <a:defPPr algn="l">
+          <a:defRPr sz="1200" b="1" dirty="0">
+            <a:solidFill>
+              <a:srgbClr val="0EA5E9"/>
+            </a:solidFill>
+            <a:latin typeface="Segoe UI"/>
+          </a:defRPr>
+        </a:defPPr>
+      </a:lstStyle>
+    </a:txDef>
   </a:objectDefaults>
   <a:extraClrSchemeLst/>
 </a:theme>

</xml_diff>